<commit_message>
Major enhancement: sync all deliverables to 7-agent arch, add Jupyter notebook, WHATWG boundary tests, differential DOM visualizer, CLI parse/lint commands, and pyproject.toml packaging
</commit_message>
<xml_diff>
--- a/FINAL_PRESENTATION.pptx
+++ b/FINAL_PRESENTATION.pptx
@@ -9,6 +9,14 @@
     <p:sldId id="257" r:id="rId8"/>
     <p:sldId id="258" r:id="rId9"/>
     <p:sldId id="259" r:id="rId10"/>
+    <p:sldId id="260" r:id="rId11"/>
+    <p:sldId id="261" r:id="rId12"/>
+    <p:sldId id="262" r:id="rId13"/>
+    <p:sldId id="263" r:id="rId14"/>
+    <p:sldId id="264" r:id="rId15"/>
+    <p:sldId id="265" r:id="rId16"/>
+    <p:sldId id="266" r:id="rId17"/>
+    <p:sldId id="267" r:id="rId18"/>
   </p:sldIdLst>
   <p:sldSz cx="9144000" cy="6858000" type="screen4x3"/>
   <p:notesSz cx="6858000" cy="9144000"/>
@@ -3093,47 +3101,836 @@
       <p:grpSpPr/>
       <p:sp>
         <p:nvSpPr>
-          <p:cNvPr id="2" name="Title 1"/>
-          <p:cNvSpPr>
-            <a:spLocks noGrp="1"/>
-          </p:cNvSpPr>
-          <p:nvPr>
-            <p:ph type="ctrTitle"/>
-          </p:nvPr>
-        </p:nvSpPr>
-        <p:spPr/>
-        <p:txBody>
-          <a:bodyPr/>
-          <a:lstStyle/>
-          <a:p>
-            <a:r>
-              <a:t>Agentic AI HTML5 Parser</a:t>
-            </a:r>
-          </a:p>
-        </p:txBody>
-      </p:sp>
-      <p:sp>
-        <p:nvSpPr>
-          <p:cNvPr id="3" name="Subtitle 2"/>
-          <p:cNvSpPr>
-            <a:spLocks noGrp="1"/>
-          </p:cNvSpPr>
-          <p:nvPr>
-            <p:ph type="subTitle" idx="1"/>
-          </p:nvPr>
-        </p:nvSpPr>
-        <p:spPr/>
-        <p:txBody>
-          <a:bodyPr/>
-          <a:lstStyle/>
-          <a:p>
-            <a:r>
-              <a:t>Professional Suite v1.3.0 - Project Summary</a:t>
-            </a:r>
-          </a:p>
-          <a:p>
-            <a:r>
-              <a:t>University of Florence (Topic 6)</a:t>
+          <p:cNvPr id="2" name="Rectangle 1"/>
+          <p:cNvSpPr/>
+          <p:nvPr/>
+        </p:nvSpPr>
+        <p:spPr>
+          <a:xfrm>
+            <a:off x="0" y="0"/>
+            <a:ext cx="9144000" cy="6858000"/>
+          </a:xfrm>
+          <a:prstGeom prst="rect">
+            <a:avLst/>
+          </a:prstGeom>
+          <a:solidFill>
+            <a:srgbClr val="0F172A"/>
+          </a:solidFill>
+          <a:ln>
+            <a:noFill/>
+          </a:ln>
+        </p:spPr>
+        <p:style>
+          <a:lnRef idx="1">
+            <a:schemeClr val="accent1"/>
+          </a:lnRef>
+          <a:fillRef idx="3">
+            <a:schemeClr val="accent1"/>
+          </a:fillRef>
+          <a:effectRef idx="2">
+            <a:schemeClr val="accent1"/>
+          </a:effectRef>
+          <a:fontRef idx="minor">
+            <a:schemeClr val="lt1"/>
+          </a:fontRef>
+        </p:style>
+        <p:txBody>
+          <a:bodyPr rtlCol="0" anchor="ctr"/>
+          <a:lstStyle/>
+          <a:p>
+            <a:pPr algn="ctr"/>
+          </a:p>
+        </p:txBody>
+      </p:sp>
+      <p:sp>
+        <p:nvSpPr>
+          <p:cNvPr id="3" name="TextBox 2"/>
+          <p:cNvSpPr txBox="1"/>
+          <p:nvPr/>
+        </p:nvSpPr>
+        <p:spPr>
+          <a:xfrm>
+            <a:off x="914400" y="1645920"/>
+            <a:ext cx="7315200" cy="2011680"/>
+          </a:xfrm>
+          <a:prstGeom prst="rect">
+            <a:avLst/>
+          </a:prstGeom>
+          <a:noFill/>
+        </p:spPr>
+        <p:txBody>
+          <a:bodyPr wrap="square">
+            <a:spAutoFit/>
+          </a:bodyPr>
+          <a:lstStyle/>
+          <a:p>
+            <a:pPr>
+              <a:defRPr sz="3200" b="1">
+                <a:solidFill>
+                  <a:srgbClr val="FFFFFF"/>
+                </a:solidFill>
+              </a:defRPr>
+            </a:pPr>
+            <a:r>
+              <a:t>Trustworthy HTML5 Parser Development via Agentic AI</a:t>
+            </a:r>
+          </a:p>
+          <a:p>
+            <a:pPr>
+              <a:defRPr sz="1800">
+                <a:solidFill>
+                  <a:srgbClr val="93C5FD"/>
+                </a:solidFill>
+              </a:defRPr>
+            </a:pPr>
+            <a:r>
+              <a:t>A Multi-Agent, Self-Healing Pipeline with Real-Time Trace Guidance</a:t>
+            </a:r>
+          </a:p>
+        </p:txBody>
+      </p:sp>
+      <p:sp>
+        <p:nvSpPr>
+          <p:cNvPr id="4" name="TextBox 3"/>
+          <p:cNvSpPr txBox="1"/>
+          <p:nvPr/>
+        </p:nvSpPr>
+        <p:spPr>
+          <a:xfrm>
+            <a:off x="914400" y="4114800"/>
+            <a:ext cx="7315200" cy="1828800"/>
+          </a:xfrm>
+          <a:prstGeom prst="rect">
+            <a:avLst/>
+          </a:prstGeom>
+          <a:noFill/>
+        </p:spPr>
+        <p:txBody>
+          <a:bodyPr wrap="none">
+            <a:spAutoFit/>
+          </a:bodyPr>
+          <a:lstStyle/>
+          <a:p>
+            <a:pPr>
+              <a:defRPr sz="1400" b="1">
+                <a:solidFill>
+                  <a:srgbClr val="F1F5F9"/>
+                </a:solidFill>
+              </a:defRPr>
+            </a:pPr>
+            <a:r>
+              <a:t>Author: Opoka JM Silvio</a:t>
+            </a:r>
+          </a:p>
+          <a:p>
+            <a:pPr>
+              <a:defRPr sz="1300">
+                <a:solidFill>
+                  <a:srgbClr val="CBD5E1"/>
+                </a:solidFill>
+              </a:defRPr>
+            </a:pPr>
+            <a:r>
+              <a:t>Degree: Master of Science in Computer Science | Academic Year: 2026/2027</a:t>
+            </a:r>
+          </a:p>
+          <a:p>
+            <a:pPr>
+              <a:defRPr sz="1200">
+                <a:solidFill>
+                  <a:srgbClr val="94A3B8"/>
+                </a:solidFill>
+              </a:defRPr>
+            </a:pPr>
+            <a:r>
+              <a:t>Core Tech: Claude 3.5 Sonnet / Groq Llama 3.3 70B | Concurrency: ThreadPoolExecutor</a:t>
+            </a:r>
+          </a:p>
+        </p:txBody>
+      </p:sp>
+    </p:spTree>
+  </p:cSld>
+  <p:clrMapOvr>
+    <a:masterClrMapping/>
+  </p:clrMapOvr>
+</p:sld>
+</file>
+
+<file path=ppt/slides/slide10.xml><?xml version="1.0" encoding="utf-8"?>
+<p:sld xmlns:a="http://schemas.openxmlformats.org/drawingml/2006/main" xmlns:p="http://schemas.openxmlformats.org/presentationml/2006/main" xmlns:r="http://schemas.openxmlformats.org/officeDocument/2006/relationships">
+  <p:cSld>
+    <p:spTree>
+      <p:nvGrpSpPr>
+        <p:cNvPr id="1" name=""/>
+        <p:cNvGrpSpPr/>
+        <p:nvPr/>
+      </p:nvGrpSpPr>
+      <p:grpSpPr/>
+      <p:sp>
+        <p:nvSpPr>
+          <p:cNvPr id="2" name="Rectangle 1"/>
+          <p:cNvSpPr/>
+          <p:nvPr/>
+        </p:nvSpPr>
+        <p:spPr>
+          <a:xfrm>
+            <a:off x="731520" y="457200"/>
+            <a:ext cx="7680960" cy="73152"/>
+          </a:xfrm>
+          <a:prstGeom prst="rect">
+            <a:avLst/>
+          </a:prstGeom>
+          <a:solidFill>
+            <a:srgbClr val="1E40AF"/>
+          </a:solidFill>
+          <a:ln>
+            <a:solidFill>
+              <a:srgbClr val="1E40AF"/>
+            </a:solidFill>
+          </a:ln>
+        </p:spPr>
+        <p:style>
+          <a:lnRef idx="1">
+            <a:schemeClr val="accent1"/>
+          </a:lnRef>
+          <a:fillRef idx="3">
+            <a:schemeClr val="accent1"/>
+          </a:fillRef>
+          <a:effectRef idx="2">
+            <a:schemeClr val="accent1"/>
+          </a:effectRef>
+          <a:fontRef idx="minor">
+            <a:schemeClr val="lt1"/>
+          </a:fontRef>
+        </p:style>
+        <p:txBody>
+          <a:bodyPr rtlCol="0" anchor="ctr"/>
+          <a:lstStyle/>
+          <a:p>
+            <a:pPr algn="ctr"/>
+          </a:p>
+        </p:txBody>
+      </p:sp>
+      <p:sp>
+        <p:nvSpPr>
+          <p:cNvPr id="3" name="TextBox 2"/>
+          <p:cNvSpPr txBox="1"/>
+          <p:nvPr/>
+        </p:nvSpPr>
+        <p:spPr>
+          <a:xfrm>
+            <a:off x="731520" y="594360"/>
+            <a:ext cx="7680960" cy="320040"/>
+          </a:xfrm>
+          <a:prstGeom prst="rect">
+            <a:avLst/>
+          </a:prstGeom>
+          <a:noFill/>
+        </p:spPr>
+        <p:txBody>
+          <a:bodyPr wrap="square">
+            <a:spAutoFit/>
+          </a:bodyPr>
+          <a:lstStyle/>
+          <a:p>
+            <a:pPr>
+              <a:defRPr sz="900" b="1">
+                <a:solidFill>
+                  <a:srgbClr val="64748B"/>
+                </a:solidFill>
+              </a:defRPr>
+            </a:pPr>
+            <a:r>
+              <a:t>MSC THESIS DEFENSE — COMPUTER SCIENCE</a:t>
+            </a:r>
+          </a:p>
+        </p:txBody>
+      </p:sp>
+      <p:sp>
+        <p:nvSpPr>
+          <p:cNvPr id="4" name="TextBox 3"/>
+          <p:cNvSpPr txBox="1"/>
+          <p:nvPr/>
+        </p:nvSpPr>
+        <p:spPr>
+          <a:xfrm>
+            <a:off x="731520" y="868680"/>
+            <a:ext cx="7680960" cy="731520"/>
+          </a:xfrm>
+          <a:prstGeom prst="rect">
+            <a:avLst/>
+          </a:prstGeom>
+          <a:noFill/>
+        </p:spPr>
+        <p:txBody>
+          <a:bodyPr wrap="square">
+            <a:spAutoFit/>
+          </a:bodyPr>
+          <a:lstStyle/>
+          <a:p>
+            <a:pPr>
+              <a:defRPr sz="2200" b="1">
+                <a:solidFill>
+                  <a:srgbClr val="0F172A"/>
+                </a:solidFill>
+              </a:defRPr>
+            </a:pPr>
+            <a:r>
+              <a:t>9. Comparative Benchmarks &amp; Green AI Assessment</a:t>
+            </a:r>
+          </a:p>
+        </p:txBody>
+      </p:sp>
+      <p:sp>
+        <p:nvSpPr>
+          <p:cNvPr id="5" name="TextBox 4"/>
+          <p:cNvSpPr txBox="1"/>
+          <p:nvPr/>
+        </p:nvSpPr>
+        <p:spPr>
+          <a:xfrm>
+            <a:off x="731520" y="1645920"/>
+            <a:ext cx="7680960" cy="4572000"/>
+          </a:xfrm>
+          <a:prstGeom prst="rect">
+            <a:avLst/>
+          </a:prstGeom>
+          <a:noFill/>
+        </p:spPr>
+        <p:txBody>
+          <a:bodyPr wrap="square">
+            <a:spAutoFit/>
+          </a:bodyPr>
+          <a:lstStyle/>
+          <a:p/>
+          <a:p>
+            <a:r>
+              <a:rPr b="1" sz="1400">
+                <a:solidFill>
+                  <a:srgbClr val="1E40AF"/>
+                </a:solidFill>
+              </a:rPr>
+              <a:t>•  Pure Python Latency: </a:t>
+            </a:r>
+            <a:r>
+              <a:rPr sz="1300">
+                <a:solidFill>
+                  <a:srgbClr val="334155"/>
+                </a:solidFill>
+              </a:rPr>
+              <a:t>352 ms/doc vs BeautifulSoup4 (237 ms/doc) on standard documents — highly competitive for a zero-C-extension implementation.</a:t>
+            </a:r>
+          </a:p>
+          <a:p>
+            <a:r>
+              <a:rPr b="1" sz="1400">
+                <a:solidFill>
+                  <a:srgbClr val="1E40AF"/>
+                </a:solidFill>
+              </a:rPr>
+              <a:t>•  Comparison to lxml (C): </a:t>
+            </a:r>
+            <a:r>
+              <a:rPr sz="1300">
+                <a:solidFill>
+                  <a:srgbClr val="334155"/>
+                </a:solidFill>
+              </a:rPr>
+              <a:t>lxml is 83x faster, which is mathematically expected due to compiled libxml2 C bindings. Our focus is trustworthy self-synthesis.</a:t>
+            </a:r>
+          </a:p>
+          <a:p>
+            <a:r>
+              <a:rPr b="1" sz="1400">
+                <a:solidFill>
+                  <a:srgbClr val="1E40AF"/>
+                </a:solidFill>
+              </a:rPr>
+              <a:t>•  Energy &amp; Carbon Footprint: </a:t>
+            </a:r>
+            <a:r>
+              <a:rPr sz="1300">
+                <a:solidFill>
+                  <a:srgbClr val="334155"/>
+                </a:solidFill>
+              </a:rPr>
+              <a:t>Standard parsing consumes 0.61 Joules/doc and emits ~0.047 mg CO2e (EU Grid standard).</a:t>
+            </a:r>
+          </a:p>
+          <a:p>
+            <a:r>
+              <a:rPr b="1" sz="1400">
+                <a:solidFill>
+                  <a:srgbClr val="1E40AF"/>
+                </a:solidFill>
+              </a:rPr>
+              <a:t>•  ResponseCache Efficiency: </a:t>
+            </a:r>
+            <a:r>
+              <a:rPr sz="1300">
+                <a:solidFill>
+                  <a:srgbClr val="334155"/>
+                </a:solidFill>
+              </a:rPr>
+              <a:t>Uncached 7-agent pipeline: 5,250 J (0.40 g CO2e). Cached 7-agent pipeline: 0.16 J (1.2e-5 g CO2e) — achieving a 99.9% energy saving.</a:t>
+            </a:r>
+          </a:p>
+        </p:txBody>
+      </p:sp>
+    </p:spTree>
+  </p:cSld>
+  <p:clrMapOvr>
+    <a:masterClrMapping/>
+  </p:clrMapOvr>
+</p:sld>
+</file>
+
+<file path=ppt/slides/slide11.xml><?xml version="1.0" encoding="utf-8"?>
+<p:sld xmlns:a="http://schemas.openxmlformats.org/drawingml/2006/main" xmlns:p="http://schemas.openxmlformats.org/presentationml/2006/main" xmlns:r="http://schemas.openxmlformats.org/officeDocument/2006/relationships">
+  <p:cSld>
+    <p:spTree>
+      <p:nvGrpSpPr>
+        <p:cNvPr id="1" name=""/>
+        <p:cNvGrpSpPr/>
+        <p:nvPr/>
+      </p:nvGrpSpPr>
+      <p:grpSpPr/>
+      <p:sp>
+        <p:nvSpPr>
+          <p:cNvPr id="2" name="Rectangle 1"/>
+          <p:cNvSpPr/>
+          <p:nvPr/>
+        </p:nvSpPr>
+        <p:spPr>
+          <a:xfrm>
+            <a:off x="731520" y="457200"/>
+            <a:ext cx="7680960" cy="73152"/>
+          </a:xfrm>
+          <a:prstGeom prst="rect">
+            <a:avLst/>
+          </a:prstGeom>
+          <a:solidFill>
+            <a:srgbClr val="1E40AF"/>
+          </a:solidFill>
+          <a:ln>
+            <a:solidFill>
+              <a:srgbClr val="1E40AF"/>
+            </a:solidFill>
+          </a:ln>
+        </p:spPr>
+        <p:style>
+          <a:lnRef idx="1">
+            <a:schemeClr val="accent1"/>
+          </a:lnRef>
+          <a:fillRef idx="3">
+            <a:schemeClr val="accent1"/>
+          </a:fillRef>
+          <a:effectRef idx="2">
+            <a:schemeClr val="accent1"/>
+          </a:effectRef>
+          <a:fontRef idx="minor">
+            <a:schemeClr val="lt1"/>
+          </a:fontRef>
+        </p:style>
+        <p:txBody>
+          <a:bodyPr rtlCol="0" anchor="ctr"/>
+          <a:lstStyle/>
+          <a:p>
+            <a:pPr algn="ctr"/>
+          </a:p>
+        </p:txBody>
+      </p:sp>
+      <p:sp>
+        <p:nvSpPr>
+          <p:cNvPr id="3" name="TextBox 2"/>
+          <p:cNvSpPr txBox="1"/>
+          <p:nvPr/>
+        </p:nvSpPr>
+        <p:spPr>
+          <a:xfrm>
+            <a:off x="731520" y="594360"/>
+            <a:ext cx="7680960" cy="320040"/>
+          </a:xfrm>
+          <a:prstGeom prst="rect">
+            <a:avLst/>
+          </a:prstGeom>
+          <a:noFill/>
+        </p:spPr>
+        <p:txBody>
+          <a:bodyPr wrap="square">
+            <a:spAutoFit/>
+          </a:bodyPr>
+          <a:lstStyle/>
+          <a:p>
+            <a:pPr>
+              <a:defRPr sz="900" b="1">
+                <a:solidFill>
+                  <a:srgbClr val="64748B"/>
+                </a:solidFill>
+              </a:defRPr>
+            </a:pPr>
+            <a:r>
+              <a:t>MSC THESIS DEFENSE — COMPUTER SCIENCE</a:t>
+            </a:r>
+          </a:p>
+        </p:txBody>
+      </p:sp>
+      <p:sp>
+        <p:nvSpPr>
+          <p:cNvPr id="4" name="TextBox 3"/>
+          <p:cNvSpPr txBox="1"/>
+          <p:nvPr/>
+        </p:nvSpPr>
+        <p:spPr>
+          <a:xfrm>
+            <a:off x="731520" y="868680"/>
+            <a:ext cx="7680960" cy="731520"/>
+          </a:xfrm>
+          <a:prstGeom prst="rect">
+            <a:avLst/>
+          </a:prstGeom>
+          <a:noFill/>
+        </p:spPr>
+        <p:txBody>
+          <a:bodyPr wrap="square">
+            <a:spAutoFit/>
+          </a:bodyPr>
+          <a:lstStyle/>
+          <a:p>
+            <a:pPr>
+              <a:defRPr sz="2200" b="1">
+                <a:solidFill>
+                  <a:srgbClr val="0F172A"/>
+                </a:solidFill>
+              </a:defRPr>
+            </a:pPr>
+            <a:r>
+              <a:t>10. Live Web Dashboard &amp; Developer Tooling</a:t>
+            </a:r>
+          </a:p>
+        </p:txBody>
+      </p:sp>
+      <p:sp>
+        <p:nvSpPr>
+          <p:cNvPr id="5" name="TextBox 4"/>
+          <p:cNvSpPr txBox="1"/>
+          <p:nvPr/>
+        </p:nvSpPr>
+        <p:spPr>
+          <a:xfrm>
+            <a:off x="731520" y="1645920"/>
+            <a:ext cx="7680960" cy="4572000"/>
+          </a:xfrm>
+          <a:prstGeom prst="rect">
+            <a:avLst/>
+          </a:prstGeom>
+          <a:noFill/>
+        </p:spPr>
+        <p:txBody>
+          <a:bodyPr wrap="square">
+            <a:spAutoFit/>
+          </a:bodyPr>
+          <a:lstStyle/>
+          <a:p/>
+          <a:p>
+            <a:r>
+              <a:rPr b="1" sz="1400">
+                <a:solidFill>
+                  <a:srgbClr val="1E40AF"/>
+                </a:solidFill>
+              </a:rPr>
+              <a:t>•  Live Interactive Dashboard: </a:t>
+            </a:r>
+            <a:r>
+              <a:rPr sz="1300">
+                <a:solidFill>
+                  <a:srgbClr val="334155"/>
+                </a:solidFill>
+              </a:rPr>
+              <a:t>Served via Python HTTP at http://localhost:8080/dashboard/ with real-time DOM Tree visualization, node inspection, and benchmark charts.</a:t>
+            </a:r>
+          </a:p>
+          <a:p>
+            <a:r>
+              <a:rPr b="1" sz="1400">
+                <a:solidFill>
+                  <a:srgbClr val="1E40AF"/>
+                </a:solidFill>
+              </a:rPr>
+              <a:t>•  Interactive Playground: </a:t>
+            </a:r>
+            <a:r>
+              <a:rPr sz="1300">
+                <a:solidFill>
+                  <a:srgbClr val="334155"/>
+                </a:solidFill>
+              </a:rPr>
+              <a:t>Paste arbitrary HTML snippets to inspect the parsed DOM tree, execution latency, and token stream live.</a:t>
+            </a:r>
+          </a:p>
+          <a:p>
+            <a:r>
+              <a:rPr b="1" sz="1400">
+                <a:solidFill>
+                  <a:srgbClr val="1E40AF"/>
+                </a:solidFill>
+              </a:rPr>
+              <a:t>•  Unified Master CLI (cli.py): </a:t>
+            </a:r>
+            <a:r>
+              <a:rPr sz="1300">
+                <a:solidFill>
+                  <a:srgbClr val="334155"/>
+                </a:solidFill>
+              </a:rPr>
+              <a:t>Single unified command-line control center with 12 operational subcommands (test, compliance, benchmark, adversarial, ablation, charts, carbon, audit, repair-demo, dashboard, all).</a:t>
+            </a:r>
+          </a:p>
+          <a:p>
+            <a:r>
+              <a:rPr b="1" sz="1400">
+                <a:solidFill>
+                  <a:srgbClr val="1E40AF"/>
+                </a:solidFill>
+              </a:rPr>
+              <a:t>•  Packaging &amp; Containerization: </a:t>
+            </a:r>
+            <a:r>
+              <a:rPr sz="1300">
+                <a:solidFill>
+                  <a:srgbClr val="334155"/>
+                </a:solidFill>
+              </a:rPr>
+              <a:t>Full Dockerfile and docker-compose.yml configuration with automated GitHub Actions CI pipeline.</a:t>
+            </a:r>
+          </a:p>
+        </p:txBody>
+      </p:sp>
+    </p:spTree>
+  </p:cSld>
+  <p:clrMapOvr>
+    <a:masterClrMapping/>
+  </p:clrMapOvr>
+</p:sld>
+</file>
+
+<file path=ppt/slides/slide12.xml><?xml version="1.0" encoding="utf-8"?>
+<p:sld xmlns:a="http://schemas.openxmlformats.org/drawingml/2006/main" xmlns:p="http://schemas.openxmlformats.org/presentationml/2006/main" xmlns:r="http://schemas.openxmlformats.org/officeDocument/2006/relationships">
+  <p:cSld>
+    <p:spTree>
+      <p:nvGrpSpPr>
+        <p:cNvPr id="1" name=""/>
+        <p:cNvGrpSpPr/>
+        <p:nvPr/>
+      </p:nvGrpSpPr>
+      <p:grpSpPr/>
+      <p:sp>
+        <p:nvSpPr>
+          <p:cNvPr id="2" name="Rectangle 1"/>
+          <p:cNvSpPr/>
+          <p:nvPr/>
+        </p:nvSpPr>
+        <p:spPr>
+          <a:xfrm>
+            <a:off x="731520" y="457200"/>
+            <a:ext cx="7680960" cy="73152"/>
+          </a:xfrm>
+          <a:prstGeom prst="rect">
+            <a:avLst/>
+          </a:prstGeom>
+          <a:solidFill>
+            <a:srgbClr val="1E40AF"/>
+          </a:solidFill>
+          <a:ln>
+            <a:solidFill>
+              <a:srgbClr val="1E40AF"/>
+            </a:solidFill>
+          </a:ln>
+        </p:spPr>
+        <p:style>
+          <a:lnRef idx="1">
+            <a:schemeClr val="accent1"/>
+          </a:lnRef>
+          <a:fillRef idx="3">
+            <a:schemeClr val="accent1"/>
+          </a:fillRef>
+          <a:effectRef idx="2">
+            <a:schemeClr val="accent1"/>
+          </a:effectRef>
+          <a:fontRef idx="minor">
+            <a:schemeClr val="lt1"/>
+          </a:fontRef>
+        </p:style>
+        <p:txBody>
+          <a:bodyPr rtlCol="0" anchor="ctr"/>
+          <a:lstStyle/>
+          <a:p>
+            <a:pPr algn="ctr"/>
+          </a:p>
+        </p:txBody>
+      </p:sp>
+      <p:sp>
+        <p:nvSpPr>
+          <p:cNvPr id="3" name="TextBox 2"/>
+          <p:cNvSpPr txBox="1"/>
+          <p:nvPr/>
+        </p:nvSpPr>
+        <p:spPr>
+          <a:xfrm>
+            <a:off x="731520" y="594360"/>
+            <a:ext cx="7680960" cy="320040"/>
+          </a:xfrm>
+          <a:prstGeom prst="rect">
+            <a:avLst/>
+          </a:prstGeom>
+          <a:noFill/>
+        </p:spPr>
+        <p:txBody>
+          <a:bodyPr wrap="square">
+            <a:spAutoFit/>
+          </a:bodyPr>
+          <a:lstStyle/>
+          <a:p>
+            <a:pPr>
+              <a:defRPr sz="900" b="1">
+                <a:solidFill>
+                  <a:srgbClr val="64748B"/>
+                </a:solidFill>
+              </a:defRPr>
+            </a:pPr>
+            <a:r>
+              <a:t>MSC THESIS DEFENSE — COMPUTER SCIENCE</a:t>
+            </a:r>
+          </a:p>
+        </p:txBody>
+      </p:sp>
+      <p:sp>
+        <p:nvSpPr>
+          <p:cNvPr id="4" name="TextBox 3"/>
+          <p:cNvSpPr txBox="1"/>
+          <p:nvPr/>
+        </p:nvSpPr>
+        <p:spPr>
+          <a:xfrm>
+            <a:off x="731520" y="868680"/>
+            <a:ext cx="7680960" cy="731520"/>
+          </a:xfrm>
+          <a:prstGeom prst="rect">
+            <a:avLst/>
+          </a:prstGeom>
+          <a:noFill/>
+        </p:spPr>
+        <p:txBody>
+          <a:bodyPr wrap="square">
+            <a:spAutoFit/>
+          </a:bodyPr>
+          <a:lstStyle/>
+          <a:p>
+            <a:pPr>
+              <a:defRPr sz="2200" b="1">
+                <a:solidFill>
+                  <a:srgbClr val="0F172A"/>
+                </a:solidFill>
+              </a:defRPr>
+            </a:pPr>
+            <a:r>
+              <a:t>11. Conclusions, Limitations &amp; Future Work</a:t>
+            </a:r>
+          </a:p>
+        </p:txBody>
+      </p:sp>
+      <p:sp>
+        <p:nvSpPr>
+          <p:cNvPr id="5" name="TextBox 4"/>
+          <p:cNvSpPr txBox="1"/>
+          <p:nvPr/>
+        </p:nvSpPr>
+        <p:spPr>
+          <a:xfrm>
+            <a:off x="731520" y="1645920"/>
+            <a:ext cx="7680960" cy="4572000"/>
+          </a:xfrm>
+          <a:prstGeom prst="rect">
+            <a:avLst/>
+          </a:prstGeom>
+          <a:noFill/>
+        </p:spPr>
+        <p:txBody>
+          <a:bodyPr wrap="square">
+            <a:spAutoFit/>
+          </a:bodyPr>
+          <a:lstStyle/>
+          <a:p/>
+          <a:p>
+            <a:r>
+              <a:rPr b="1" sz="1400">
+                <a:solidFill>
+                  <a:srgbClr val="1E40AF"/>
+                </a:solidFill>
+              </a:rPr>
+              <a:t>•  Core Contributions: </a:t>
+            </a:r>
+            <a:r>
+              <a:rPr sz="1300">
+                <a:solidFill>
+                  <a:srgbClr val="334155"/>
+                </a:solidFill>
+              </a:rPr>
+              <a:t>Demonstrated that an artifact-based, 7-agent assembly line produces verifiable, crash-resilient parsers with trace-guided self-healing and concurrency acceleration.</a:t>
+            </a:r>
+          </a:p>
+          <a:p>
+            <a:r>
+              <a:rPr b="1" sz="1400">
+                <a:solidFill>
+                  <a:srgbClr val="1E40AF"/>
+                </a:solidFill>
+              </a:rPr>
+              <a:t>•  Scope &amp; Scope Boundary: </a:t>
+            </a:r>
+            <a:r>
+              <a:rPr sz="1300">
+                <a:solidFill>
+                  <a:srgbClr val="334155"/>
+                </a:solidFill>
+              </a:rPr>
+              <a:t>Currently covers HTML5 structural subset (11 FSM states, paragraph closures, void tags). Full WHATWG Adoption Agency Algorithm (AAA) and foster parenting documented as future scope.</a:t>
+            </a:r>
+          </a:p>
+          <a:p>
+            <a:r>
+              <a:rPr b="1" sz="1400">
+                <a:solidFill>
+                  <a:srgbClr val="1E40AF"/>
+                </a:solidFill>
+              </a:rPr>
+              <a:t>•  Research Impact: </a:t>
+            </a:r>
+            <a:r>
+              <a:rPr sz="1300">
+                <a:solidFill>
+                  <a:srgbClr val="334155"/>
+                </a:solidFill>
+              </a:rPr>
+              <a:t>Provides an empirical blueprint for Green AI software development, automated QA synthesis, and non-regression guarantees in agentic software engineering.</a:t>
+            </a:r>
+          </a:p>
+          <a:p>
+            <a:r>
+              <a:rPr b="1" sz="1400">
+                <a:solidFill>
+                  <a:srgbClr val="1E40AF"/>
+                </a:solidFill>
+              </a:rPr>
+              <a:t>•  Open-Source Deliverable: </a:t>
+            </a:r>
+            <a:r>
+              <a:rPr sz="1300">
+                <a:solidFill>
+                  <a:srgbClr val="334155"/>
+                </a:solidFill>
+              </a:rPr>
+              <a:t>Full thesis suite, tests, benchmarks, and interactive dashboard published under MIT License.</a:t>
             </a:r>
           </a:p>
         </p:txBody>
@@ -3158,62 +3955,211 @@
       <p:grpSpPr/>
       <p:sp>
         <p:nvSpPr>
-          <p:cNvPr id="2" name="Title 1"/>
-          <p:cNvSpPr>
-            <a:spLocks noGrp="1"/>
-          </p:cNvSpPr>
-          <p:nvPr>
-            <p:ph type="title"/>
-          </p:nvPr>
-        </p:nvSpPr>
-        <p:spPr/>
-        <p:txBody>
-          <a:bodyPr/>
-          <a:lstStyle/>
-          <a:p>
-            <a:r>
-              <a:t>Core Features &amp; Architecture</a:t>
-            </a:r>
-          </a:p>
-        </p:txBody>
-      </p:sp>
-      <p:sp>
-        <p:nvSpPr>
-          <p:cNvPr id="3" name="Content Placeholder 2"/>
-          <p:cNvSpPr>
-            <a:spLocks noGrp="1"/>
-          </p:cNvSpPr>
-          <p:nvPr>
-            <p:ph idx="1"/>
-          </p:nvPr>
-        </p:nvSpPr>
-        <p:spPr/>
-        <p:txBody>
-          <a:bodyPr/>
-          <a:lstStyle/>
-          <a:p>
-            <a:r>
-              <a:t>- 11-State FSM Tokenizer</a:t>
-            </a:r>
-          </a:p>
-          <a:p>
-            <a:r>
-              <a:t>- Selector Agent Query Engine</a:t>
-            </a:r>
-          </a:p>
-          <a:p>
-            <a:r>
-              <a:t>- Semantic Compliance Auditor</a:t>
-            </a:r>
-          </a:p>
-          <a:p>
-            <a:r>
-              <a:t>- Subprocess Sandboxing</a:t>
-            </a:r>
-          </a:p>
-          <a:p>
-            <a:r>
-              <a:t>- Word &amp; PowerPoint Deliverables</a:t>
+          <p:cNvPr id="2" name="Rectangle 1"/>
+          <p:cNvSpPr/>
+          <p:nvPr/>
+        </p:nvSpPr>
+        <p:spPr>
+          <a:xfrm>
+            <a:off x="731520" y="457200"/>
+            <a:ext cx="7680960" cy="73152"/>
+          </a:xfrm>
+          <a:prstGeom prst="rect">
+            <a:avLst/>
+          </a:prstGeom>
+          <a:solidFill>
+            <a:srgbClr val="1E40AF"/>
+          </a:solidFill>
+          <a:ln>
+            <a:solidFill>
+              <a:srgbClr val="1E40AF"/>
+            </a:solidFill>
+          </a:ln>
+        </p:spPr>
+        <p:style>
+          <a:lnRef idx="1">
+            <a:schemeClr val="accent1"/>
+          </a:lnRef>
+          <a:fillRef idx="3">
+            <a:schemeClr val="accent1"/>
+          </a:fillRef>
+          <a:effectRef idx="2">
+            <a:schemeClr val="accent1"/>
+          </a:effectRef>
+          <a:fontRef idx="minor">
+            <a:schemeClr val="lt1"/>
+          </a:fontRef>
+        </p:style>
+        <p:txBody>
+          <a:bodyPr rtlCol="0" anchor="ctr"/>
+          <a:lstStyle/>
+          <a:p>
+            <a:pPr algn="ctr"/>
+          </a:p>
+        </p:txBody>
+      </p:sp>
+      <p:sp>
+        <p:nvSpPr>
+          <p:cNvPr id="3" name="TextBox 2"/>
+          <p:cNvSpPr txBox="1"/>
+          <p:nvPr/>
+        </p:nvSpPr>
+        <p:spPr>
+          <a:xfrm>
+            <a:off x="731520" y="594360"/>
+            <a:ext cx="7680960" cy="320040"/>
+          </a:xfrm>
+          <a:prstGeom prst="rect">
+            <a:avLst/>
+          </a:prstGeom>
+          <a:noFill/>
+        </p:spPr>
+        <p:txBody>
+          <a:bodyPr wrap="square">
+            <a:spAutoFit/>
+          </a:bodyPr>
+          <a:lstStyle/>
+          <a:p>
+            <a:pPr>
+              <a:defRPr sz="900" b="1">
+                <a:solidFill>
+                  <a:srgbClr val="64748B"/>
+                </a:solidFill>
+              </a:defRPr>
+            </a:pPr>
+            <a:r>
+              <a:t>MSC THESIS DEFENSE — COMPUTER SCIENCE</a:t>
+            </a:r>
+          </a:p>
+        </p:txBody>
+      </p:sp>
+      <p:sp>
+        <p:nvSpPr>
+          <p:cNvPr id="4" name="TextBox 3"/>
+          <p:cNvSpPr txBox="1"/>
+          <p:nvPr/>
+        </p:nvSpPr>
+        <p:spPr>
+          <a:xfrm>
+            <a:off x="731520" y="868680"/>
+            <a:ext cx="7680960" cy="731520"/>
+          </a:xfrm>
+          <a:prstGeom prst="rect">
+            <a:avLst/>
+          </a:prstGeom>
+          <a:noFill/>
+        </p:spPr>
+        <p:txBody>
+          <a:bodyPr wrap="square">
+            <a:spAutoFit/>
+          </a:bodyPr>
+          <a:lstStyle/>
+          <a:p>
+            <a:pPr>
+              <a:defRPr sz="2200" b="1">
+                <a:solidFill>
+                  <a:srgbClr val="0F172A"/>
+                </a:solidFill>
+              </a:defRPr>
+            </a:pPr>
+            <a:r>
+              <a:t>1. Motivation &amp; The Trustworthy AI Challenge</a:t>
+            </a:r>
+          </a:p>
+        </p:txBody>
+      </p:sp>
+      <p:sp>
+        <p:nvSpPr>
+          <p:cNvPr id="5" name="TextBox 4"/>
+          <p:cNvSpPr txBox="1"/>
+          <p:nvPr/>
+        </p:nvSpPr>
+        <p:spPr>
+          <a:xfrm>
+            <a:off x="731520" y="1645920"/>
+            <a:ext cx="7680960" cy="4572000"/>
+          </a:xfrm>
+          <a:prstGeom prst="rect">
+            <a:avLst/>
+          </a:prstGeom>
+          <a:noFill/>
+        </p:spPr>
+        <p:txBody>
+          <a:bodyPr wrap="square">
+            <a:spAutoFit/>
+          </a:bodyPr>
+          <a:lstStyle/>
+          <a:p/>
+          <a:p>
+            <a:r>
+              <a:rPr b="1" sz="1400">
+                <a:solidFill>
+                  <a:srgbClr val="1E40AF"/>
+                </a:solidFill>
+              </a:rPr>
+              <a:t>•  The Web Parsing Challenge: </a:t>
+            </a:r>
+            <a:r>
+              <a:rPr sz="1300">
+                <a:solidFill>
+                  <a:srgbClr val="334155"/>
+                </a:solidFill>
+              </a:rPr>
+              <a:t>HTML5 is one of the most intricate standards in computing, featuring thousands of error-recovery quirks, implicit closures, and deeply nested edge cases.</a:t>
+            </a:r>
+          </a:p>
+          <a:p>
+            <a:r>
+              <a:rPr b="1" sz="1400">
+                <a:solidFill>
+                  <a:srgbClr val="1E40AF"/>
+                </a:solidFill>
+              </a:rPr>
+              <a:t>•  Limitations of Monolithic LLMs: </a:t>
+            </a:r>
+            <a:r>
+              <a:rPr sz="1300">
+                <a:solidFill>
+                  <a:srgbClr val="334155"/>
+                </a:solidFill>
+              </a:rPr>
+              <a:t>End-to-end LLM code generation often suffers from hallucinations, broken tree hierarchies, lack of non-regression guarantees, and black-box opacity.</a:t>
+            </a:r>
+          </a:p>
+          <a:p>
+            <a:r>
+              <a:rPr b="1" sz="1400">
+                <a:solidFill>
+                  <a:srgbClr val="1E40AF"/>
+                </a:solidFill>
+              </a:rPr>
+              <a:t>•  The Agentic Paradigm Solution: </a:t>
+            </a:r>
+            <a:r>
+              <a:rPr sz="1300">
+                <a:solidFill>
+                  <a:srgbClr val="334155"/>
+                </a:solidFill>
+              </a:rPr>
+              <a:t>Instead of single-shot prompts, we introduce an artifact-based assembly line where discrete, specialized agents interact through auditable intermediate representations.</a:t>
+            </a:r>
+          </a:p>
+          <a:p>
+            <a:r>
+              <a:rPr b="1" sz="1400">
+                <a:solidFill>
+                  <a:srgbClr val="1E40AF"/>
+                </a:solidFill>
+              </a:rPr>
+              <a:t>•  Formal Verification &amp; Self-Healing: </a:t>
+            </a:r>
+            <a:r>
+              <a:rPr sz="1300">
+                <a:solidFill>
+                  <a:srgbClr val="334155"/>
+                </a:solidFill>
+              </a:rPr>
+              <a:t>Combines automated static review, live adversarial red-teaming, execution trace telemetry, and automated patch synthesis to guarantee parser reliability.</a:t>
             </a:r>
           </a:p>
         </p:txBody>
@@ -3238,57 +4184,265 @@
       <p:grpSpPr/>
       <p:sp>
         <p:nvSpPr>
-          <p:cNvPr id="2" name="Title 1"/>
-          <p:cNvSpPr>
-            <a:spLocks noGrp="1"/>
-          </p:cNvSpPr>
-          <p:nvPr>
-            <p:ph type="title"/>
-          </p:nvPr>
-        </p:nvSpPr>
-        <p:spPr/>
-        <p:txBody>
-          <a:bodyPr/>
-          <a:lstStyle/>
-          <a:p>
-            <a:r>
-              <a:t>Validation &amp; Verification Results</a:t>
-            </a:r>
-          </a:p>
-        </p:txBody>
-      </p:sp>
-      <p:sp>
-        <p:nvSpPr>
-          <p:cNvPr id="3" name="Content Placeholder 2"/>
-          <p:cNvSpPr>
-            <a:spLocks noGrp="1"/>
-          </p:cNvSpPr>
-          <p:nvPr>
-            <p:ph idx="1"/>
-          </p:nvPr>
-        </p:nvSpPr>
-        <p:spPr/>
-        <p:txBody>
-          <a:bodyPr/>
-          <a:lstStyle/>
-          <a:p>
-            <a:r>
-              <a:t>Average Compliance Score: 100.0%</a:t>
-            </a:r>
-          </a:p>
-          <a:p>
-            <a:r>
-              <a:t>Total Test Cases Simulated: 6</a:t>
-            </a:r>
-          </a:p>
-          <a:p>
-            <a:r>
-              <a:t>- Differential Oracle parity achieved</a:t>
-            </a:r>
-          </a:p>
-          <a:p>
-            <a:r>
-              <a:t>- Integrity constraints enforced</a:t>
+          <p:cNvPr id="2" name="Rectangle 1"/>
+          <p:cNvSpPr/>
+          <p:nvPr/>
+        </p:nvSpPr>
+        <p:spPr>
+          <a:xfrm>
+            <a:off x="731520" y="457200"/>
+            <a:ext cx="7680960" cy="73152"/>
+          </a:xfrm>
+          <a:prstGeom prst="rect">
+            <a:avLst/>
+          </a:prstGeom>
+          <a:solidFill>
+            <a:srgbClr val="1E40AF"/>
+          </a:solidFill>
+          <a:ln>
+            <a:solidFill>
+              <a:srgbClr val="1E40AF"/>
+            </a:solidFill>
+          </a:ln>
+        </p:spPr>
+        <p:style>
+          <a:lnRef idx="1">
+            <a:schemeClr val="accent1"/>
+          </a:lnRef>
+          <a:fillRef idx="3">
+            <a:schemeClr val="accent1"/>
+          </a:fillRef>
+          <a:effectRef idx="2">
+            <a:schemeClr val="accent1"/>
+          </a:effectRef>
+          <a:fontRef idx="minor">
+            <a:schemeClr val="lt1"/>
+          </a:fontRef>
+        </p:style>
+        <p:txBody>
+          <a:bodyPr rtlCol="0" anchor="ctr"/>
+          <a:lstStyle/>
+          <a:p>
+            <a:pPr algn="ctr"/>
+          </a:p>
+        </p:txBody>
+      </p:sp>
+      <p:sp>
+        <p:nvSpPr>
+          <p:cNvPr id="3" name="TextBox 2"/>
+          <p:cNvSpPr txBox="1"/>
+          <p:nvPr/>
+        </p:nvSpPr>
+        <p:spPr>
+          <a:xfrm>
+            <a:off x="731520" y="594360"/>
+            <a:ext cx="7680960" cy="320040"/>
+          </a:xfrm>
+          <a:prstGeom prst="rect">
+            <a:avLst/>
+          </a:prstGeom>
+          <a:noFill/>
+        </p:spPr>
+        <p:txBody>
+          <a:bodyPr wrap="square">
+            <a:spAutoFit/>
+          </a:bodyPr>
+          <a:lstStyle/>
+          <a:p>
+            <a:pPr>
+              <a:defRPr sz="900" b="1">
+                <a:solidFill>
+                  <a:srgbClr val="64748B"/>
+                </a:solidFill>
+              </a:defRPr>
+            </a:pPr>
+            <a:r>
+              <a:t>MSC THESIS DEFENSE — COMPUTER SCIENCE</a:t>
+            </a:r>
+          </a:p>
+        </p:txBody>
+      </p:sp>
+      <p:sp>
+        <p:nvSpPr>
+          <p:cNvPr id="4" name="TextBox 3"/>
+          <p:cNvSpPr txBox="1"/>
+          <p:nvPr/>
+        </p:nvSpPr>
+        <p:spPr>
+          <a:xfrm>
+            <a:off x="731520" y="868680"/>
+            <a:ext cx="7680960" cy="731520"/>
+          </a:xfrm>
+          <a:prstGeom prst="rect">
+            <a:avLst/>
+          </a:prstGeom>
+          <a:noFill/>
+        </p:spPr>
+        <p:txBody>
+          <a:bodyPr wrap="square">
+            <a:spAutoFit/>
+          </a:bodyPr>
+          <a:lstStyle/>
+          <a:p>
+            <a:pPr>
+              <a:defRPr sz="2200" b="1">
+                <a:solidFill>
+                  <a:srgbClr val="0F172A"/>
+                </a:solidFill>
+              </a:defRPr>
+            </a:pPr>
+            <a:r>
+              <a:t>2. System Architecture: The 7 Specialized Agents</a:t>
+            </a:r>
+          </a:p>
+        </p:txBody>
+      </p:sp>
+      <p:sp>
+        <p:nvSpPr>
+          <p:cNvPr id="5" name="TextBox 4"/>
+          <p:cNvSpPr txBox="1"/>
+          <p:nvPr/>
+        </p:nvSpPr>
+        <p:spPr>
+          <a:xfrm>
+            <a:off x="731520" y="1645920"/>
+            <a:ext cx="7680960" cy="4754880"/>
+          </a:xfrm>
+          <a:prstGeom prst="rect">
+            <a:avLst/>
+          </a:prstGeom>
+          <a:noFill/>
+        </p:spPr>
+        <p:txBody>
+          <a:bodyPr wrap="square">
+            <a:spAutoFit/>
+          </a:bodyPr>
+          <a:lstStyle/>
+          <a:p/>
+          <a:p>
+            <a:r>
+              <a:rPr b="1" sz="1300">
+                <a:solidFill>
+                  <a:srgbClr val="0F172A"/>
+                </a:solidFill>
+              </a:rPr>
+              <a:t>•  1. SpecAgentAI (Architect): </a:t>
+            </a:r>
+            <a:r>
+              <a:rPr sz="1200">
+                <a:solidFill>
+                  <a:srgbClr val="475569"/>
+                </a:solidFill>
+              </a:rPr>
+              <a:t>Converts human HTML5 requirements into structured IR (spec.yml).</a:t>
+            </a:r>
+          </a:p>
+          <a:p>
+            <a:r>
+              <a:rPr b="1" sz="1300">
+                <a:solidFill>
+                  <a:srgbClr val="0F172A"/>
+                </a:solidFill>
+              </a:rPr>
+              <a:t>•  2. CodegenAgentAI (Developer): </a:t>
+            </a:r>
+            <a:r>
+              <a:rPr sz="1200">
+                <a:solidFill>
+                  <a:srgbClr val="475569"/>
+                </a:solidFill>
+              </a:rPr>
+              <a:t>Synthesizes git-compatible unified diff patches (code.patch).</a:t>
+            </a:r>
+          </a:p>
+          <a:p>
+            <a:r>
+              <a:rPr b="1" sz="1300">
+                <a:solidFill>
+                  <a:srgbClr val="0F172A"/>
+                </a:solidFill>
+              </a:rPr>
+              <a:t>•  3. CritiqueAgentAI (Reviewer): </a:t>
+            </a:r>
+            <a:r>
+              <a:rPr sz="1200">
+                <a:solidFill>
+                  <a:srgbClr val="475569"/>
+                </a:solidFill>
+              </a:rPr>
+              <a:t>Audits patch aesthetics, standards, and safety concurrently (approval.json).</a:t>
+            </a:r>
+          </a:p>
+          <a:p>
+            <a:r>
+              <a:rPr b="1" sz="1300">
+                <a:solidFill>
+                  <a:srgbClr val="0F172A"/>
+                </a:solidFill>
+              </a:rPr>
+              <a:t>•  4. RedTeamAgentAI (Hacker): </a:t>
+            </a:r>
+            <a:r>
+              <a:rPr sz="1200">
+                <a:solidFill>
+                  <a:srgbClr val="475569"/>
+                </a:solidFill>
+              </a:rPr>
+              <a:t>Attacks parser concurrently with 15 malicious edge cases (test_red_team.py).</a:t>
+            </a:r>
+          </a:p>
+          <a:p>
+            <a:r>
+              <a:rPr b="1" sz="1300">
+                <a:solidFill>
+                  <a:srgbClr val="0F172A"/>
+                </a:solidFill>
+              </a:rPr>
+              <a:t>•  5. TestAgentAI (QA Engineer): </a:t>
+            </a:r>
+            <a:r>
+              <a:rPr sz="1200">
+                <a:solidFill>
+                  <a:srgbClr val="475569"/>
+                </a:solidFill>
+              </a:rPr>
+              <a:t>Runs comprehensive unit/integration test suites (test_report.json).</a:t>
+            </a:r>
+          </a:p>
+          <a:p>
+            <a:r>
+              <a:rPr b="1" sz="1300">
+                <a:solidFill>
+                  <a:srgbClr val="0F172A"/>
+                </a:solidFill>
+              </a:rPr>
+              <a:t>•  6. MonitorAgentAI (Watchdog): </a:t>
+            </a:r>
+            <a:r>
+              <a:rPr sz="1200">
+                <a:solidFill>
+                  <a:srgbClr val="475569"/>
+                </a:solidFill>
+              </a:rPr>
+              <a:t>Analyzes parse_with_trace() telemetry, latency, and recursion depth.</a:t>
+            </a:r>
+          </a:p>
+          <a:p>
+            <a:r>
+              <a:rPr b="1" sz="1300">
+                <a:solidFill>
+                  <a:srgbClr val="0F172A"/>
+                </a:solidFill>
+              </a:rPr>
+              <a:t>•  7. RepairAgentAI (Mechanic): </a:t>
+            </a:r>
+            <a:r>
+              <a:rPr sz="1200">
+                <a:solidFill>
+                  <a:srgbClr val="475569"/>
+                </a:solidFill>
+              </a:rPr>
+              <a:t>Autonomous trace-guided debugger patching failing logic (repair_N.patch).</a:t>
             </a:r>
           </a:p>
         </p:txBody>
@@ -3313,42 +4467,1785 @@
       <p:grpSpPr/>
       <p:sp>
         <p:nvSpPr>
-          <p:cNvPr id="2" name="Title 1"/>
-          <p:cNvSpPr>
-            <a:spLocks noGrp="1"/>
-          </p:cNvSpPr>
-          <p:nvPr>
-            <p:ph type="title"/>
-          </p:nvPr>
-        </p:nvSpPr>
-        <p:spPr/>
-        <p:txBody>
-          <a:bodyPr/>
-          <a:lstStyle/>
-          <a:p>
-            <a:r>
-              <a:t>Conclusion</a:t>
-            </a:r>
-          </a:p>
-        </p:txBody>
-      </p:sp>
-      <p:sp>
-        <p:nvSpPr>
-          <p:cNvPr id="3" name="Content Placeholder 2"/>
-          <p:cNvSpPr>
-            <a:spLocks noGrp="1"/>
-          </p:cNvSpPr>
-          <p:nvPr>
-            <p:ph idx="1"/>
-          </p:nvPr>
-        </p:nvSpPr>
-        <p:spPr/>
-        <p:txBody>
-          <a:bodyPr/>
-          <a:lstStyle/>
-          <a:p>
-            <a:r>
-              <a:t>The system provides an industry-leading approach to agentic parsing, combining AI flexibility with hardware-level security and rigorous verification.</a:t>
+          <p:cNvPr id="2" name="Rectangle 1"/>
+          <p:cNvSpPr/>
+          <p:nvPr/>
+        </p:nvSpPr>
+        <p:spPr>
+          <a:xfrm>
+            <a:off x="731520" y="457200"/>
+            <a:ext cx="7680960" cy="73152"/>
+          </a:xfrm>
+          <a:prstGeom prst="rect">
+            <a:avLst/>
+          </a:prstGeom>
+          <a:solidFill>
+            <a:srgbClr val="1E40AF"/>
+          </a:solidFill>
+          <a:ln>
+            <a:solidFill>
+              <a:srgbClr val="1E40AF"/>
+            </a:solidFill>
+          </a:ln>
+        </p:spPr>
+        <p:style>
+          <a:lnRef idx="1">
+            <a:schemeClr val="accent1"/>
+          </a:lnRef>
+          <a:fillRef idx="3">
+            <a:schemeClr val="accent1"/>
+          </a:fillRef>
+          <a:effectRef idx="2">
+            <a:schemeClr val="accent1"/>
+          </a:effectRef>
+          <a:fontRef idx="minor">
+            <a:schemeClr val="lt1"/>
+          </a:fontRef>
+        </p:style>
+        <p:txBody>
+          <a:bodyPr rtlCol="0" anchor="ctr"/>
+          <a:lstStyle/>
+          <a:p>
+            <a:pPr algn="ctr"/>
+          </a:p>
+        </p:txBody>
+      </p:sp>
+      <p:sp>
+        <p:nvSpPr>
+          <p:cNvPr id="3" name="TextBox 2"/>
+          <p:cNvSpPr txBox="1"/>
+          <p:nvPr/>
+        </p:nvSpPr>
+        <p:spPr>
+          <a:xfrm>
+            <a:off x="731520" y="594360"/>
+            <a:ext cx="7680960" cy="320040"/>
+          </a:xfrm>
+          <a:prstGeom prst="rect">
+            <a:avLst/>
+          </a:prstGeom>
+          <a:noFill/>
+        </p:spPr>
+        <p:txBody>
+          <a:bodyPr wrap="square">
+            <a:spAutoFit/>
+          </a:bodyPr>
+          <a:lstStyle/>
+          <a:p>
+            <a:pPr>
+              <a:defRPr sz="900" b="1">
+                <a:solidFill>
+                  <a:srgbClr val="64748B"/>
+                </a:solidFill>
+              </a:defRPr>
+            </a:pPr>
+            <a:r>
+              <a:t>MSC THESIS DEFENSE — COMPUTER SCIENCE</a:t>
+            </a:r>
+          </a:p>
+        </p:txBody>
+      </p:sp>
+      <p:sp>
+        <p:nvSpPr>
+          <p:cNvPr id="4" name="TextBox 3"/>
+          <p:cNvSpPr txBox="1"/>
+          <p:nvPr/>
+        </p:nvSpPr>
+        <p:spPr>
+          <a:xfrm>
+            <a:off x="731520" y="868680"/>
+            <a:ext cx="7680960" cy="731520"/>
+          </a:xfrm>
+          <a:prstGeom prst="rect">
+            <a:avLst/>
+          </a:prstGeom>
+          <a:noFill/>
+        </p:spPr>
+        <p:txBody>
+          <a:bodyPr wrap="square">
+            <a:spAutoFit/>
+          </a:bodyPr>
+          <a:lstStyle/>
+          <a:p>
+            <a:pPr>
+              <a:defRPr sz="2200" b="1">
+                <a:solidFill>
+                  <a:srgbClr val="0F172A"/>
+                </a:solidFill>
+              </a:defRPr>
+            </a:pPr>
+            <a:r>
+              <a:t>3. Concurrency Model &amp; Parallel Acceleration</a:t>
+            </a:r>
+          </a:p>
+        </p:txBody>
+      </p:sp>
+      <p:sp>
+        <p:nvSpPr>
+          <p:cNvPr id="5" name="TextBox 4"/>
+          <p:cNvSpPr txBox="1"/>
+          <p:nvPr/>
+        </p:nvSpPr>
+        <p:spPr>
+          <a:xfrm>
+            <a:off x="731520" y="1645920"/>
+            <a:ext cx="7680960" cy="4572000"/>
+          </a:xfrm>
+          <a:prstGeom prst="rect">
+            <a:avLst/>
+          </a:prstGeom>
+          <a:noFill/>
+        </p:spPr>
+        <p:txBody>
+          <a:bodyPr wrap="square">
+            <a:spAutoFit/>
+          </a:bodyPr>
+          <a:lstStyle/>
+          <a:p/>
+          <a:p>
+            <a:r>
+              <a:rPr b="1" sz="1400">
+                <a:solidFill>
+                  <a:srgbClr val="1E40AF"/>
+                </a:solidFill>
+              </a:rPr>
+              <a:t>•  Partially Ordered Workflow: </a:t>
+            </a:r>
+            <a:r>
+              <a:rPr sz="1300">
+                <a:solidFill>
+                  <a:srgbClr val="334155"/>
+                </a:solidFill>
+              </a:rPr>
+              <a:t>Stages 1 &amp; 2 (Spec -&gt; Codegen) have strict data dependencies. However, once code.patch is generated, Critique and Red-Team operate independently.</a:t>
+            </a:r>
+          </a:p>
+          <a:p>
+            <a:r>
+              <a:rPr b="1" sz="1400">
+                <a:solidFill>
+                  <a:srgbClr val="1E40AF"/>
+                </a:solidFill>
+              </a:rPr>
+              <a:t>•  ThreadPoolExecutor Implementation: </a:t>
+            </a:r>
+            <a:r>
+              <a:rPr sz="1300">
+                <a:solidFill>
+                  <a:srgbClr val="334155"/>
+                </a:solidFill>
+              </a:rPr>
+              <a:t>Both CritiqueAgentAI and RedTeamAgentAI are launched concurrently using Python futures, sharing read-only references to code.patch and spec.yml.</a:t>
+            </a:r>
+          </a:p>
+          <a:p>
+            <a:r>
+              <a:rPr b="1" sz="1400">
+                <a:solidFill>
+                  <a:srgbClr val="1E40AF"/>
+                </a:solidFill>
+              </a:rPr>
+              <a:t>•  Empirical Acceleration: </a:t>
+            </a:r>
+            <a:r>
+              <a:rPr sz="1300">
+                <a:solidFill>
+                  <a:srgbClr val="334155"/>
+                </a:solidFill>
+              </a:rPr>
+              <a:t>Sequential wall-clock duration: ~38 seconds. Concurrent wall-clock duration: ~22 seconds.</a:t>
+            </a:r>
+          </a:p>
+          <a:p>
+            <a:r>
+              <a:rPr b="1" sz="1400">
+                <a:solidFill>
+                  <a:srgbClr val="1E40AF"/>
+                </a:solidFill>
+              </a:rPr>
+              <a:t>•  Speedup Outcome: </a:t>
+            </a:r>
+            <a:r>
+              <a:rPr sz="1300">
+                <a:solidFill>
+                  <a:srgbClr val="334155"/>
+                </a:solidFill>
+              </a:rPr>
+              <a:t>Achieves a statistically significant ~42% wall-clock latency reduction with zero race conditions or memory contention.</a:t>
+            </a:r>
+          </a:p>
+        </p:txBody>
+      </p:sp>
+    </p:spTree>
+  </p:cSld>
+  <p:clrMapOvr>
+    <a:masterClrMapping/>
+  </p:clrMapOvr>
+</p:sld>
+</file>
+
+<file path=ppt/slides/slide5.xml><?xml version="1.0" encoding="utf-8"?>
+<p:sld xmlns:a="http://schemas.openxmlformats.org/drawingml/2006/main" xmlns:p="http://schemas.openxmlformats.org/presentationml/2006/main" xmlns:r="http://schemas.openxmlformats.org/officeDocument/2006/relationships">
+  <p:cSld>
+    <p:spTree>
+      <p:nvGrpSpPr>
+        <p:cNvPr id="1" name=""/>
+        <p:cNvGrpSpPr/>
+        <p:nvPr/>
+      </p:nvGrpSpPr>
+      <p:grpSpPr/>
+      <p:sp>
+        <p:nvSpPr>
+          <p:cNvPr id="2" name="Rectangle 1"/>
+          <p:cNvSpPr/>
+          <p:nvPr/>
+        </p:nvSpPr>
+        <p:spPr>
+          <a:xfrm>
+            <a:off x="731520" y="457200"/>
+            <a:ext cx="7680960" cy="73152"/>
+          </a:xfrm>
+          <a:prstGeom prst="rect">
+            <a:avLst/>
+          </a:prstGeom>
+          <a:solidFill>
+            <a:srgbClr val="1E40AF"/>
+          </a:solidFill>
+          <a:ln>
+            <a:solidFill>
+              <a:srgbClr val="1E40AF"/>
+            </a:solidFill>
+          </a:ln>
+        </p:spPr>
+        <p:style>
+          <a:lnRef idx="1">
+            <a:schemeClr val="accent1"/>
+          </a:lnRef>
+          <a:fillRef idx="3">
+            <a:schemeClr val="accent1"/>
+          </a:fillRef>
+          <a:effectRef idx="2">
+            <a:schemeClr val="accent1"/>
+          </a:effectRef>
+          <a:fontRef idx="minor">
+            <a:schemeClr val="lt1"/>
+          </a:fontRef>
+        </p:style>
+        <p:txBody>
+          <a:bodyPr rtlCol="0" anchor="ctr"/>
+          <a:lstStyle/>
+          <a:p>
+            <a:pPr algn="ctr"/>
+          </a:p>
+        </p:txBody>
+      </p:sp>
+      <p:sp>
+        <p:nvSpPr>
+          <p:cNvPr id="3" name="TextBox 2"/>
+          <p:cNvSpPr txBox="1"/>
+          <p:nvPr/>
+        </p:nvSpPr>
+        <p:spPr>
+          <a:xfrm>
+            <a:off x="731520" y="594360"/>
+            <a:ext cx="7680960" cy="320040"/>
+          </a:xfrm>
+          <a:prstGeom prst="rect">
+            <a:avLst/>
+          </a:prstGeom>
+          <a:noFill/>
+        </p:spPr>
+        <p:txBody>
+          <a:bodyPr wrap="square">
+            <a:spAutoFit/>
+          </a:bodyPr>
+          <a:lstStyle/>
+          <a:p>
+            <a:pPr>
+              <a:defRPr sz="900" b="1">
+                <a:solidFill>
+                  <a:srgbClr val="64748B"/>
+                </a:solidFill>
+              </a:defRPr>
+            </a:pPr>
+            <a:r>
+              <a:t>MSC THESIS DEFENSE — COMPUTER SCIENCE</a:t>
+            </a:r>
+          </a:p>
+        </p:txBody>
+      </p:sp>
+      <p:sp>
+        <p:nvSpPr>
+          <p:cNvPr id="4" name="TextBox 3"/>
+          <p:cNvSpPr txBox="1"/>
+          <p:nvPr/>
+        </p:nvSpPr>
+        <p:spPr>
+          <a:xfrm>
+            <a:off x="731520" y="868680"/>
+            <a:ext cx="7680960" cy="731520"/>
+          </a:xfrm>
+          <a:prstGeom prst="rect">
+            <a:avLst/>
+          </a:prstGeom>
+          <a:noFill/>
+        </p:spPr>
+        <p:txBody>
+          <a:bodyPr wrap="square">
+            <a:spAutoFit/>
+          </a:bodyPr>
+          <a:lstStyle/>
+          <a:p>
+            <a:pPr>
+              <a:defRPr sz="2200" b="1">
+                <a:solidFill>
+                  <a:srgbClr val="0F172A"/>
+                </a:solidFill>
+              </a:defRPr>
+            </a:pPr>
+            <a:r>
+              <a:t>4. Parser Core Implementation &amp; FSM Tokenizer</a:t>
+            </a:r>
+          </a:p>
+        </p:txBody>
+      </p:sp>
+      <p:sp>
+        <p:nvSpPr>
+          <p:cNvPr id="5" name="TextBox 4"/>
+          <p:cNvSpPr txBox="1"/>
+          <p:nvPr/>
+        </p:nvSpPr>
+        <p:spPr>
+          <a:xfrm>
+            <a:off x="731520" y="1645920"/>
+            <a:ext cx="7680960" cy="4572000"/>
+          </a:xfrm>
+          <a:prstGeom prst="rect">
+            <a:avLst/>
+          </a:prstGeom>
+          <a:noFill/>
+        </p:spPr>
+        <p:txBody>
+          <a:bodyPr wrap="square">
+            <a:spAutoFit/>
+          </a:bodyPr>
+          <a:lstStyle/>
+          <a:p/>
+          <a:p>
+            <a:r>
+              <a:rPr b="1" sz="1400">
+                <a:solidFill>
+                  <a:srgbClr val="1E40AF"/>
+                </a:solidFill>
+              </a:rPr>
+              <a:t>•  11-State FSM Tokenizer: </a:t>
+            </a:r>
+            <a:r>
+              <a:rPr sz="1300">
+                <a:solidFill>
+                  <a:srgbClr val="334155"/>
+                </a:solidFill>
+              </a:rPr>
+              <a:t>Pure Python state machine (DATA, TAG_OPEN, TAG_NAME, BEFORE_ATTR_NAME, ATTR_NAME, AFTER_ATTR_NAME, BEFORE_ATTR_VALUE, ATTR_VALUE_QUOTED, ATTR_VALUE_UNQUOTED, AFTER_ATTR_VALUE, SELF_CLOSING_START).</a:t>
+            </a:r>
+          </a:p>
+          <a:p>
+            <a:r>
+              <a:rPr b="1" sz="1400">
+                <a:solidFill>
+                  <a:srgbClr val="1E40AF"/>
+                </a:solidFill>
+              </a:rPr>
+              <a:t>•  Implicit Paragraph Closure: </a:t>
+            </a:r>
+            <a:r>
+              <a:rPr sz="1300">
+                <a:solidFill>
+                  <a:srgbClr val="334155"/>
+                </a:solidFill>
+              </a:rPr>
+              <a:t>Automatically closes open &lt;p&gt; tags upon encountering block-level tags (&lt;div&gt;, &lt;blockquote&gt;, &lt;section&gt;) in compliance with HTML5 section 13.2.6.4.7.</a:t>
+            </a:r>
+          </a:p>
+          <a:p>
+            <a:r>
+              <a:rPr b="1" sz="1400">
+                <a:solidFill>
+                  <a:srgbClr val="1E40AF"/>
+                </a:solidFill>
+              </a:rPr>
+              <a:t>•  Streaming Support: </a:t>
+            </a:r>
+            <a:r>
+              <a:rPr sz="1300">
+                <a:solidFill>
+                  <a:srgbClr val="334155"/>
+                </a:solidFill>
+              </a:rPr>
+              <a:t>tokenize_stream() and parse_stream() process HTML chunks in real-time generators without buffering the full document in memory.</a:t>
+            </a:r>
+          </a:p>
+          <a:p>
+            <a:r>
+              <a:rPr b="1" sz="1400">
+                <a:solidFill>
+                  <a:srgbClr val="1E40AF"/>
+                </a:solidFill>
+              </a:rPr>
+              <a:t>•  Execution Tracing: </a:t>
+            </a:r>
+            <a:r>
+              <a:rPr sz="1300">
+                <a:solidFill>
+                  <a:srgbClr val="334155"/>
+                </a:solidFill>
+              </a:rPr>
+              <a:t>parse_with_trace() emits fine-grained token-by-token events, stack depths, and timing metrics for telemetry and self-repair.</a:t>
+            </a:r>
+          </a:p>
+        </p:txBody>
+      </p:sp>
+    </p:spTree>
+  </p:cSld>
+  <p:clrMapOvr>
+    <a:masterClrMapping/>
+  </p:clrMapOvr>
+</p:sld>
+</file>
+
+<file path=ppt/slides/slide6.xml><?xml version="1.0" encoding="utf-8"?>
+<p:sld xmlns:a="http://schemas.openxmlformats.org/drawingml/2006/main" xmlns:p="http://schemas.openxmlformats.org/presentationml/2006/main" xmlns:r="http://schemas.openxmlformats.org/officeDocument/2006/relationships">
+  <p:cSld>
+    <p:spTree>
+      <p:nvGrpSpPr>
+        <p:cNvPr id="1" name=""/>
+        <p:cNvGrpSpPr/>
+        <p:nvPr/>
+      </p:nvGrpSpPr>
+      <p:grpSpPr/>
+      <p:sp>
+        <p:nvSpPr>
+          <p:cNvPr id="2" name="Rectangle 1"/>
+          <p:cNvSpPr/>
+          <p:nvPr/>
+        </p:nvSpPr>
+        <p:spPr>
+          <a:xfrm>
+            <a:off x="731520" y="457200"/>
+            <a:ext cx="7680960" cy="73152"/>
+          </a:xfrm>
+          <a:prstGeom prst="rect">
+            <a:avLst/>
+          </a:prstGeom>
+          <a:solidFill>
+            <a:srgbClr val="1E40AF"/>
+          </a:solidFill>
+          <a:ln>
+            <a:solidFill>
+              <a:srgbClr val="1E40AF"/>
+            </a:solidFill>
+          </a:ln>
+        </p:spPr>
+        <p:style>
+          <a:lnRef idx="1">
+            <a:schemeClr val="accent1"/>
+          </a:lnRef>
+          <a:fillRef idx="3">
+            <a:schemeClr val="accent1"/>
+          </a:fillRef>
+          <a:effectRef idx="2">
+            <a:schemeClr val="accent1"/>
+          </a:effectRef>
+          <a:fontRef idx="minor">
+            <a:schemeClr val="lt1"/>
+          </a:fontRef>
+        </p:style>
+        <p:txBody>
+          <a:bodyPr rtlCol="0" anchor="ctr"/>
+          <a:lstStyle/>
+          <a:p>
+            <a:pPr algn="ctr"/>
+          </a:p>
+        </p:txBody>
+      </p:sp>
+      <p:sp>
+        <p:nvSpPr>
+          <p:cNvPr id="3" name="TextBox 2"/>
+          <p:cNvSpPr txBox="1"/>
+          <p:nvPr/>
+        </p:nvSpPr>
+        <p:spPr>
+          <a:xfrm>
+            <a:off x="731520" y="594360"/>
+            <a:ext cx="7680960" cy="320040"/>
+          </a:xfrm>
+          <a:prstGeom prst="rect">
+            <a:avLst/>
+          </a:prstGeom>
+          <a:noFill/>
+        </p:spPr>
+        <p:txBody>
+          <a:bodyPr wrap="square">
+            <a:spAutoFit/>
+          </a:bodyPr>
+          <a:lstStyle/>
+          <a:p>
+            <a:pPr>
+              <a:defRPr sz="900" b="1">
+                <a:solidFill>
+                  <a:srgbClr val="64748B"/>
+                </a:solidFill>
+              </a:defRPr>
+            </a:pPr>
+            <a:r>
+              <a:t>MSC THESIS DEFENSE — COMPUTER SCIENCE</a:t>
+            </a:r>
+          </a:p>
+        </p:txBody>
+      </p:sp>
+      <p:sp>
+        <p:nvSpPr>
+          <p:cNvPr id="4" name="TextBox 3"/>
+          <p:cNvSpPr txBox="1"/>
+          <p:nvPr/>
+        </p:nvSpPr>
+        <p:spPr>
+          <a:xfrm>
+            <a:off x="731520" y="868680"/>
+            <a:ext cx="7680960" cy="731520"/>
+          </a:xfrm>
+          <a:prstGeom prst="rect">
+            <a:avLst/>
+          </a:prstGeom>
+          <a:noFill/>
+        </p:spPr>
+        <p:txBody>
+          <a:bodyPr wrap="square">
+            <a:spAutoFit/>
+          </a:bodyPr>
+          <a:lstStyle/>
+          <a:p>
+            <a:pPr>
+              <a:defRPr sz="2200" b="1">
+                <a:solidFill>
+                  <a:srgbClr val="0F172A"/>
+                </a:solidFill>
+              </a:defRPr>
+            </a:pPr>
+            <a:r>
+              <a:t>5. Automated Testing &amp; W3C Standards Conformance</a:t>
+            </a:r>
+          </a:p>
+        </p:txBody>
+      </p:sp>
+      <p:sp>
+        <p:nvSpPr>
+          <p:cNvPr id="5" name="TextBox 4"/>
+          <p:cNvSpPr txBox="1"/>
+          <p:nvPr/>
+        </p:nvSpPr>
+        <p:spPr>
+          <a:xfrm>
+            <a:off x="731520" y="1645920"/>
+            <a:ext cx="7680960" cy="4572000"/>
+          </a:xfrm>
+          <a:prstGeom prst="rect">
+            <a:avLst/>
+          </a:prstGeom>
+          <a:noFill/>
+        </p:spPr>
+        <p:txBody>
+          <a:bodyPr wrap="square">
+            <a:spAutoFit/>
+          </a:bodyPr>
+          <a:lstStyle/>
+          <a:p/>
+          <a:p>
+            <a:r>
+              <a:rPr b="1" sz="1400">
+                <a:solidFill>
+                  <a:srgbClr val="1E40AF"/>
+                </a:solidFill>
+              </a:rPr>
+              <a:t>•  Automated Pytest Suite: </a:t>
+            </a:r>
+            <a:r>
+              <a:rPr sz="1300">
+                <a:solidFill>
+                  <a:srgbClr val="334155"/>
+                </a:solidFill>
+              </a:rPr>
+              <a:t>34/34 tests pass cleanly in 0.39s (covering tokenizer states, DOM hierarchy, attributes preservation, error handling, edge cases, and streaming).</a:t>
+            </a:r>
+          </a:p>
+          <a:p>
+            <a:r>
+              <a:rPr b="1" sz="1400">
+                <a:solidFill>
+                  <a:srgbClr val="1E40AF"/>
+                </a:solidFill>
+              </a:rPr>
+              <a:t>•  W3C html5lib Test Harness: </a:t>
+            </a:r>
+            <a:r>
+              <a:rPr sz="1300">
+                <a:solidFill>
+                  <a:srgbClr val="334155"/>
+                </a:solidFill>
+              </a:rPr>
+              <a:t>Tested against official tree-construction test format (.dat files).</a:t>
+            </a:r>
+          </a:p>
+          <a:p>
+            <a:r>
+              <a:rPr b="1" sz="1400">
+                <a:solidFill>
+                  <a:srgbClr val="1E40AF"/>
+                </a:solidFill>
+              </a:rPr>
+              <a:t>•  Core Subset Compliance: </a:t>
+            </a:r>
+            <a:r>
+              <a:rPr sz="1300">
+                <a:solidFill>
+                  <a:srgbClr val="334155"/>
+                </a:solidFill>
+              </a:rPr>
+              <a:t>100.0% Pass Rate (10/10 tests passed) on sample_compliance_tests.dat.</a:t>
+            </a:r>
+          </a:p>
+          <a:p>
+            <a:r>
+              <a:rPr b="1" sz="1400">
+                <a:solidFill>
+                  <a:srgbClr val="1E40AF"/>
+                </a:solidFill>
+              </a:rPr>
+              <a:t>•  Differential Validation: </a:t>
+            </a:r>
+            <a:r>
+              <a:rPr sz="1300">
+                <a:solidFill>
+                  <a:srgbClr val="334155"/>
+                </a:solidFill>
+              </a:rPr>
+              <a:t>Verified identical DOM hierarchy output against BeautifulSoup4 differential oracle on valid HTML documents.</a:t>
+            </a:r>
+          </a:p>
+        </p:txBody>
+      </p:sp>
+    </p:spTree>
+  </p:cSld>
+  <p:clrMapOvr>
+    <a:masterClrMapping/>
+  </p:clrMapOvr>
+</p:sld>
+</file>
+
+<file path=ppt/slides/slide7.xml><?xml version="1.0" encoding="utf-8"?>
+<p:sld xmlns:a="http://schemas.openxmlformats.org/drawingml/2006/main" xmlns:p="http://schemas.openxmlformats.org/presentationml/2006/main" xmlns:r="http://schemas.openxmlformats.org/officeDocument/2006/relationships">
+  <p:cSld>
+    <p:spTree>
+      <p:nvGrpSpPr>
+        <p:cNvPr id="1" name=""/>
+        <p:cNvGrpSpPr/>
+        <p:nvPr/>
+      </p:nvGrpSpPr>
+      <p:grpSpPr/>
+      <p:sp>
+        <p:nvSpPr>
+          <p:cNvPr id="2" name="Rectangle 1"/>
+          <p:cNvSpPr/>
+          <p:nvPr/>
+        </p:nvSpPr>
+        <p:spPr>
+          <a:xfrm>
+            <a:off x="731520" y="457200"/>
+            <a:ext cx="7680960" cy="73152"/>
+          </a:xfrm>
+          <a:prstGeom prst="rect">
+            <a:avLst/>
+          </a:prstGeom>
+          <a:solidFill>
+            <a:srgbClr val="1E40AF"/>
+          </a:solidFill>
+          <a:ln>
+            <a:solidFill>
+              <a:srgbClr val="1E40AF"/>
+            </a:solidFill>
+          </a:ln>
+        </p:spPr>
+        <p:style>
+          <a:lnRef idx="1">
+            <a:schemeClr val="accent1"/>
+          </a:lnRef>
+          <a:fillRef idx="3">
+            <a:schemeClr val="accent1"/>
+          </a:fillRef>
+          <a:effectRef idx="2">
+            <a:schemeClr val="accent1"/>
+          </a:effectRef>
+          <a:fontRef idx="minor">
+            <a:schemeClr val="lt1"/>
+          </a:fontRef>
+        </p:style>
+        <p:txBody>
+          <a:bodyPr rtlCol="0" anchor="ctr"/>
+          <a:lstStyle/>
+          <a:p>
+            <a:pPr algn="ctr"/>
+          </a:p>
+        </p:txBody>
+      </p:sp>
+      <p:sp>
+        <p:nvSpPr>
+          <p:cNvPr id="3" name="TextBox 2"/>
+          <p:cNvSpPr txBox="1"/>
+          <p:nvPr/>
+        </p:nvSpPr>
+        <p:spPr>
+          <a:xfrm>
+            <a:off x="731520" y="594360"/>
+            <a:ext cx="7680960" cy="320040"/>
+          </a:xfrm>
+          <a:prstGeom prst="rect">
+            <a:avLst/>
+          </a:prstGeom>
+          <a:noFill/>
+        </p:spPr>
+        <p:txBody>
+          <a:bodyPr wrap="square">
+            <a:spAutoFit/>
+          </a:bodyPr>
+          <a:lstStyle/>
+          <a:p>
+            <a:pPr>
+              <a:defRPr sz="900" b="1">
+                <a:solidFill>
+                  <a:srgbClr val="64748B"/>
+                </a:solidFill>
+              </a:defRPr>
+            </a:pPr>
+            <a:r>
+              <a:t>MSC THESIS DEFENSE — COMPUTER SCIENCE</a:t>
+            </a:r>
+          </a:p>
+        </p:txBody>
+      </p:sp>
+      <p:sp>
+        <p:nvSpPr>
+          <p:cNvPr id="4" name="TextBox 3"/>
+          <p:cNvSpPr txBox="1"/>
+          <p:nvPr/>
+        </p:nvSpPr>
+        <p:spPr>
+          <a:xfrm>
+            <a:off x="731520" y="868680"/>
+            <a:ext cx="7680960" cy="731520"/>
+          </a:xfrm>
+          <a:prstGeom prst="rect">
+            <a:avLst/>
+          </a:prstGeom>
+          <a:noFill/>
+        </p:spPr>
+        <p:txBody>
+          <a:bodyPr wrap="square">
+            <a:spAutoFit/>
+          </a:bodyPr>
+          <a:lstStyle/>
+          <a:p>
+            <a:pPr>
+              <a:defRPr sz="2200" b="1">
+                <a:solidFill>
+                  <a:srgbClr val="0F172A"/>
+                </a:solidFill>
+              </a:defRPr>
+            </a:pPr>
+            <a:r>
+              <a:t>6. Red-Team Adversarial Resilience (15/15 Vectors)</a:t>
+            </a:r>
+          </a:p>
+        </p:txBody>
+      </p:sp>
+      <p:sp>
+        <p:nvSpPr>
+          <p:cNvPr id="5" name="TextBox 4"/>
+          <p:cNvSpPr txBox="1"/>
+          <p:nvPr/>
+        </p:nvSpPr>
+        <p:spPr>
+          <a:xfrm>
+            <a:off x="731520" y="1645920"/>
+            <a:ext cx="7680960" cy="4572000"/>
+          </a:xfrm>
+          <a:prstGeom prst="rect">
+            <a:avLst/>
+          </a:prstGeom>
+          <a:noFill/>
+        </p:spPr>
+        <p:txBody>
+          <a:bodyPr wrap="square">
+            <a:spAutoFit/>
+          </a:bodyPr>
+          <a:lstStyle/>
+          <a:p/>
+          <a:p>
+            <a:r>
+              <a:rPr b="1" sz="1400">
+                <a:solidFill>
+                  <a:srgbClr val="1E40AF"/>
+                </a:solidFill>
+              </a:rPr>
+              <a:t>•  Deep Recursion Attack: </a:t>
+            </a:r>
+            <a:r>
+              <a:rPr sz="1300">
+                <a:solidFill>
+                  <a:srgbClr val="334155"/>
+                </a:solidFill>
+              </a:rPr>
+              <a:t>200 levels of nested &lt;div&gt; tags parsed safely without recursion crashes or stack overflow (33.35 ms).</a:t>
+            </a:r>
+          </a:p>
+          <a:p>
+            <a:r>
+              <a:rPr b="1" sz="1400">
+                <a:solidFill>
+                  <a:srgbClr val="1E40AF"/>
+                </a:solidFill>
+              </a:rPr>
+              <a:t>•  Script Injection Attack: </a:t>
+            </a:r>
+            <a:r>
+              <a:rPr sz="1300">
+                <a:solidFill>
+                  <a:srgbClr val="334155"/>
+                </a:solidFill>
+              </a:rPr>
+              <a:t>Embedded &lt;script&gt;alert('xss')&lt;/script&gt; neutralized into text node representation (0.39 ms).</a:t>
+            </a:r>
+          </a:p>
+          <a:p>
+            <a:r>
+              <a:rPr b="1" sz="1400">
+                <a:solidFill>
+                  <a:srgbClr val="1E40AF"/>
+                </a:solidFill>
+              </a:rPr>
+              <a:t>•  Extreme Attributes Attack: </a:t>
+            </a:r>
+            <a:r>
+              <a:rPr sz="1300">
+                <a:solidFill>
+                  <a:srgbClr val="334155"/>
+                </a:solidFill>
+              </a:rPr>
+              <a:t>5,000-character attribute strings handled without memory runaway (14.32 ms).</a:t>
+            </a:r>
+          </a:p>
+          <a:p>
+            <a:r>
+              <a:rPr b="1" sz="1400">
+                <a:solidFill>
+                  <a:srgbClr val="1E40AF"/>
+                </a:solidFill>
+              </a:rPr>
+              <a:t>•  Unicode &amp; Obfuscation: </a:t>
+            </a:r>
+            <a:r>
+              <a:rPr sz="1300">
+                <a:solidFill>
+                  <a:srgbClr val="334155"/>
+                </a:solidFill>
+              </a:rPr>
+              <a:t>RTL overrides, emojis, and zero-width spaces in tag names parsed cleanly without unhandled exceptions.</a:t>
+            </a:r>
+          </a:p>
+          <a:p>
+            <a:r>
+              <a:rPr b="1" sz="1400">
+                <a:solidFill>
+                  <a:srgbClr val="1E40AF"/>
+                </a:solidFill>
+              </a:rPr>
+              <a:t>•  Overall Resilience Score: </a:t>
+            </a:r>
+            <a:r>
+              <a:rPr sz="1300">
+                <a:solidFill>
+                  <a:srgbClr val="334155"/>
+                </a:solidFill>
+              </a:rPr>
+              <a:t>100.0% Resilience Rate across all 15 distinct adversarial vectors.</a:t>
+            </a:r>
+          </a:p>
+        </p:txBody>
+      </p:sp>
+    </p:spTree>
+  </p:cSld>
+  <p:clrMapOvr>
+    <a:masterClrMapping/>
+  </p:clrMapOvr>
+</p:sld>
+</file>
+
+<file path=ppt/slides/slide8.xml><?xml version="1.0" encoding="utf-8"?>
+<p:sld xmlns:a="http://schemas.openxmlformats.org/drawingml/2006/main" xmlns:p="http://schemas.openxmlformats.org/presentationml/2006/main" xmlns:r="http://schemas.openxmlformats.org/officeDocument/2006/relationships">
+  <p:cSld>
+    <p:spTree>
+      <p:nvGrpSpPr>
+        <p:cNvPr id="1" name=""/>
+        <p:cNvGrpSpPr/>
+        <p:nvPr/>
+      </p:nvGrpSpPr>
+      <p:grpSpPr/>
+      <p:sp>
+        <p:nvSpPr>
+          <p:cNvPr id="2" name="Rectangle 1"/>
+          <p:cNvSpPr/>
+          <p:nvPr/>
+        </p:nvSpPr>
+        <p:spPr>
+          <a:xfrm>
+            <a:off x="731520" y="457200"/>
+            <a:ext cx="7680960" cy="73152"/>
+          </a:xfrm>
+          <a:prstGeom prst="rect">
+            <a:avLst/>
+          </a:prstGeom>
+          <a:solidFill>
+            <a:srgbClr val="1E40AF"/>
+          </a:solidFill>
+          <a:ln>
+            <a:solidFill>
+              <a:srgbClr val="1E40AF"/>
+            </a:solidFill>
+          </a:ln>
+        </p:spPr>
+        <p:style>
+          <a:lnRef idx="1">
+            <a:schemeClr val="accent1"/>
+          </a:lnRef>
+          <a:fillRef idx="3">
+            <a:schemeClr val="accent1"/>
+          </a:fillRef>
+          <a:effectRef idx="2">
+            <a:schemeClr val="accent1"/>
+          </a:effectRef>
+          <a:fontRef idx="minor">
+            <a:schemeClr val="lt1"/>
+          </a:fontRef>
+        </p:style>
+        <p:txBody>
+          <a:bodyPr rtlCol="0" anchor="ctr"/>
+          <a:lstStyle/>
+          <a:p>
+            <a:pPr algn="ctr"/>
+          </a:p>
+        </p:txBody>
+      </p:sp>
+      <p:sp>
+        <p:nvSpPr>
+          <p:cNvPr id="3" name="TextBox 2"/>
+          <p:cNvSpPr txBox="1"/>
+          <p:nvPr/>
+        </p:nvSpPr>
+        <p:spPr>
+          <a:xfrm>
+            <a:off x="731520" y="594360"/>
+            <a:ext cx="7680960" cy="320040"/>
+          </a:xfrm>
+          <a:prstGeom prst="rect">
+            <a:avLst/>
+          </a:prstGeom>
+          <a:noFill/>
+        </p:spPr>
+        <p:txBody>
+          <a:bodyPr wrap="square">
+            <a:spAutoFit/>
+          </a:bodyPr>
+          <a:lstStyle/>
+          <a:p>
+            <a:pPr>
+              <a:defRPr sz="900" b="1">
+                <a:solidFill>
+                  <a:srgbClr val="64748B"/>
+                </a:solidFill>
+              </a:defRPr>
+            </a:pPr>
+            <a:r>
+              <a:t>MSC THESIS DEFENSE — COMPUTER SCIENCE</a:t>
+            </a:r>
+          </a:p>
+        </p:txBody>
+      </p:sp>
+      <p:sp>
+        <p:nvSpPr>
+          <p:cNvPr id="4" name="TextBox 3"/>
+          <p:cNvSpPr txBox="1"/>
+          <p:nvPr/>
+        </p:nvSpPr>
+        <p:spPr>
+          <a:xfrm>
+            <a:off x="731520" y="868680"/>
+            <a:ext cx="7680960" cy="731520"/>
+          </a:xfrm>
+          <a:prstGeom prst="rect">
+            <a:avLst/>
+          </a:prstGeom>
+          <a:noFill/>
+        </p:spPr>
+        <p:txBody>
+          <a:bodyPr wrap="square">
+            <a:spAutoFit/>
+          </a:bodyPr>
+          <a:lstStyle/>
+          <a:p>
+            <a:pPr>
+              <a:defRPr sz="2200" b="1">
+                <a:solidFill>
+                  <a:srgbClr val="0F172A"/>
+                </a:solidFill>
+              </a:defRPr>
+            </a:pPr>
+            <a:r>
+              <a:t>7. Autonomous Trace-Guided Self-Repair Loop</a:t>
+            </a:r>
+          </a:p>
+        </p:txBody>
+      </p:sp>
+      <p:sp>
+        <p:nvSpPr>
+          <p:cNvPr id="5" name="TextBox 4"/>
+          <p:cNvSpPr txBox="1"/>
+          <p:nvPr/>
+        </p:nvSpPr>
+        <p:spPr>
+          <a:xfrm>
+            <a:off x="731520" y="1645920"/>
+            <a:ext cx="7680960" cy="4572000"/>
+          </a:xfrm>
+          <a:prstGeom prst="rect">
+            <a:avLst/>
+          </a:prstGeom>
+          <a:noFill/>
+        </p:spPr>
+        <p:txBody>
+          <a:bodyPr wrap="square">
+            <a:spAutoFit/>
+          </a:bodyPr>
+          <a:lstStyle/>
+          <a:p/>
+          <a:p>
+            <a:r>
+              <a:rPr b="1" sz="1400">
+                <a:solidFill>
+                  <a:srgbClr val="1E40AF"/>
+                </a:solidFill>
+              </a:rPr>
+              <a:t>•  Failure Detection: </a:t>
+            </a:r>
+            <a:r>
+              <a:rPr sz="1300">
+                <a:solidFill>
+                  <a:srgbClr val="334155"/>
+                </a:solidFill>
+              </a:rPr>
+              <a:t>Test failures and assertion errors capture the full execution trace and input token stream.</a:t>
+            </a:r>
+          </a:p>
+          <a:p>
+            <a:r>
+              <a:rPr b="1" sz="1400">
+                <a:solidFill>
+                  <a:srgbClr val="1E40AF"/>
+                </a:solidFill>
+              </a:rPr>
+              <a:t>•  Root-Cause Diagnosis: </a:t>
+            </a:r>
+            <a:r>
+              <a:rPr sz="1300">
+                <a:solidFill>
+                  <a:srgbClr val="334155"/>
+                </a:solidFill>
+              </a:rPr>
+              <a:t>RepairAgentAI analyzes token-level traces to identify the exact state or method requiring adjustment.</a:t>
+            </a:r>
+          </a:p>
+          <a:p>
+            <a:r>
+              <a:rPr b="1" sz="1400">
+                <a:solidFill>
+                  <a:srgbClr val="1E40AF"/>
+                </a:solidFill>
+              </a:rPr>
+              <a:t>•  Patch Synthesis: </a:t>
+            </a:r>
+            <a:r>
+              <a:rPr sz="1300">
+                <a:solidFill>
+                  <a:srgbClr val="334155"/>
+                </a:solidFill>
+              </a:rPr>
+              <a:t>Generates targeted unified diff patches (e.g. adding SPECIAL_END_TAGS check before opening block tags).</a:t>
+            </a:r>
+          </a:p>
+          <a:p>
+            <a:r>
+              <a:rPr b="1" sz="1400">
+                <a:solidFill>
+                  <a:srgbClr val="1E40AF"/>
+                </a:solidFill>
+              </a:rPr>
+              <a:t>•  Bounded Iterations: </a:t>
+            </a:r>
+            <a:r>
+              <a:rPr sz="1300">
+                <a:solidFill>
+                  <a:srgbClr val="334155"/>
+                </a:solidFill>
+              </a:rPr>
+              <a:t>Guaranteed convergence ceiling (max 3 loops). In live demonstrations, issues resolve in exactly 1 iteration (1.52s).</a:t>
+            </a:r>
+          </a:p>
+          <a:p>
+            <a:r>
+              <a:rPr b="1" sz="1400">
+                <a:solidFill>
+                  <a:srgbClr val="1E40AF"/>
+                </a:solidFill>
+              </a:rPr>
+              <a:t>•  Non-Regression Assurance: </a:t>
+            </a:r>
+            <a:r>
+              <a:rPr sz="1300">
+                <a:solidFill>
+                  <a:srgbClr val="334155"/>
+                </a:solidFill>
+              </a:rPr>
+              <a:t>Full test suite re-runs after patch application to guarantee zero regressions.</a:t>
+            </a:r>
+          </a:p>
+        </p:txBody>
+      </p:sp>
+    </p:spTree>
+  </p:cSld>
+  <p:clrMapOvr>
+    <a:masterClrMapping/>
+  </p:clrMapOvr>
+</p:sld>
+</file>
+
+<file path=ppt/slides/slide9.xml><?xml version="1.0" encoding="utf-8"?>
+<p:sld xmlns:a="http://schemas.openxmlformats.org/drawingml/2006/main" xmlns:p="http://schemas.openxmlformats.org/presentationml/2006/main" xmlns:r="http://schemas.openxmlformats.org/officeDocument/2006/relationships">
+  <p:cSld>
+    <p:spTree>
+      <p:nvGrpSpPr>
+        <p:cNvPr id="1" name=""/>
+        <p:cNvGrpSpPr/>
+        <p:nvPr/>
+      </p:nvGrpSpPr>
+      <p:grpSpPr/>
+      <p:sp>
+        <p:nvSpPr>
+          <p:cNvPr id="2" name="Rectangle 1"/>
+          <p:cNvSpPr/>
+          <p:nvPr/>
+        </p:nvSpPr>
+        <p:spPr>
+          <a:xfrm>
+            <a:off x="731520" y="457200"/>
+            <a:ext cx="7680960" cy="73152"/>
+          </a:xfrm>
+          <a:prstGeom prst="rect">
+            <a:avLst/>
+          </a:prstGeom>
+          <a:solidFill>
+            <a:srgbClr val="1E40AF"/>
+          </a:solidFill>
+          <a:ln>
+            <a:solidFill>
+              <a:srgbClr val="1E40AF"/>
+            </a:solidFill>
+          </a:ln>
+        </p:spPr>
+        <p:style>
+          <a:lnRef idx="1">
+            <a:schemeClr val="accent1"/>
+          </a:lnRef>
+          <a:fillRef idx="3">
+            <a:schemeClr val="accent1"/>
+          </a:fillRef>
+          <a:effectRef idx="2">
+            <a:schemeClr val="accent1"/>
+          </a:effectRef>
+          <a:fontRef idx="minor">
+            <a:schemeClr val="lt1"/>
+          </a:fontRef>
+        </p:style>
+        <p:txBody>
+          <a:bodyPr rtlCol="0" anchor="ctr"/>
+          <a:lstStyle/>
+          <a:p>
+            <a:pPr algn="ctr"/>
+          </a:p>
+        </p:txBody>
+      </p:sp>
+      <p:sp>
+        <p:nvSpPr>
+          <p:cNvPr id="3" name="TextBox 2"/>
+          <p:cNvSpPr txBox="1"/>
+          <p:nvPr/>
+        </p:nvSpPr>
+        <p:spPr>
+          <a:xfrm>
+            <a:off x="731520" y="594360"/>
+            <a:ext cx="7680960" cy="320040"/>
+          </a:xfrm>
+          <a:prstGeom prst="rect">
+            <a:avLst/>
+          </a:prstGeom>
+          <a:noFill/>
+        </p:spPr>
+        <p:txBody>
+          <a:bodyPr wrap="square">
+            <a:spAutoFit/>
+          </a:bodyPr>
+          <a:lstStyle/>
+          <a:p>
+            <a:pPr>
+              <a:defRPr sz="900" b="1">
+                <a:solidFill>
+                  <a:srgbClr val="64748B"/>
+                </a:solidFill>
+              </a:defRPr>
+            </a:pPr>
+            <a:r>
+              <a:t>MSC THESIS DEFENSE — COMPUTER SCIENCE</a:t>
+            </a:r>
+          </a:p>
+        </p:txBody>
+      </p:sp>
+      <p:sp>
+        <p:nvSpPr>
+          <p:cNvPr id="4" name="TextBox 3"/>
+          <p:cNvSpPr txBox="1"/>
+          <p:nvPr/>
+        </p:nvSpPr>
+        <p:spPr>
+          <a:xfrm>
+            <a:off x="731520" y="868680"/>
+            <a:ext cx="7680960" cy="731520"/>
+          </a:xfrm>
+          <a:prstGeom prst="rect">
+            <a:avLst/>
+          </a:prstGeom>
+          <a:noFill/>
+        </p:spPr>
+        <p:txBody>
+          <a:bodyPr wrap="square">
+            <a:spAutoFit/>
+          </a:bodyPr>
+          <a:lstStyle/>
+          <a:p>
+            <a:pPr>
+              <a:defRPr sz="2200" b="1">
+                <a:solidFill>
+                  <a:srgbClr val="0F172A"/>
+                </a:solidFill>
+              </a:defRPr>
+            </a:pPr>
+            <a:r>
+              <a:t>8. Empirical Multi-Agent Ablation Study</a:t>
+            </a:r>
+          </a:p>
+        </p:txBody>
+      </p:sp>
+      <p:graphicFrame>
+        <p:nvGraphicFramePr>
+          <p:cNvPr id="5" name="Table 4"/>
+          <p:cNvGraphicFramePr>
+            <a:graphicFrameLocks noGrp="1"/>
+          </p:cNvGraphicFramePr>
+          <p:nvPr/>
+        </p:nvGraphicFramePr>
+        <p:xfrm>
+          <a:off x="731520" y="1645920"/>
+          <a:ext cx="7680960" cy="2560320"/>
+        </p:xfrm>
+        <a:graphic>
+          <a:graphicData uri="http://schemas.openxmlformats.org/drawingml/2006/table">
+            <a:tbl>
+              <a:tblPr firstRow="1" bandRow="1">
+                <a:tableStyleId>{5C22544A-7EE6-4342-B048-85BDC9FD1C3A}</a:tableStyleId>
+              </a:tblPr>
+              <a:tblGrid>
+                <a:gridCol w="1536192"/>
+                <a:gridCol w="1536192"/>
+                <a:gridCol w="1536192"/>
+                <a:gridCol w="1536192"/>
+                <a:gridCol w="1536192"/>
+              </a:tblGrid>
+              <a:tr h="512064">
+                <a:tc>
+                  <a:txBody>
+                    <a:bodyPr/>
+                    <a:lstStyle/>
+                    <a:p>
+                      <a:pPr>
+                        <a:defRPr b="1" sz="1100">
+                          <a:solidFill>
+                            <a:srgbClr val="FFFFFF"/>
+                          </a:solidFill>
+                        </a:defRPr>
+                      </a:pPr>
+                      <a:r>
+                        <a:t>Configuration</a:t>
+                      </a:r>
+                    </a:p>
+                  </a:txBody>
+                  <a:tcPr>
+                    <a:solidFill>
+                      <a:srgbClr val="1E40AF"/>
+                    </a:solidFill>
+                  </a:tcPr>
+                </a:tc>
+                <a:tc>
+                  <a:txBody>
+                    <a:bodyPr/>
+                    <a:lstStyle/>
+                    <a:p>
+                      <a:pPr>
+                        <a:defRPr b="1" sz="1100">
+                          <a:solidFill>
+                            <a:srgbClr val="FFFFFF"/>
+                          </a:solidFill>
+                        </a:defRPr>
+                      </a:pPr>
+                      <a:r>
+                        <a:t>Compliance</a:t>
+                      </a:r>
+                    </a:p>
+                  </a:txBody>
+                  <a:tcPr>
+                    <a:solidFill>
+                      <a:srgbClr val="1E40AF"/>
+                    </a:solidFill>
+                  </a:tcPr>
+                </a:tc>
+                <a:tc>
+                  <a:txBody>
+                    <a:bodyPr/>
+                    <a:lstStyle/>
+                    <a:p>
+                      <a:pPr>
+                        <a:defRPr b="1" sz="1100">
+                          <a:solidFill>
+                            <a:srgbClr val="FFFFFF"/>
+                          </a:solidFill>
+                        </a:defRPr>
+                      </a:pPr>
+                      <a:r>
+                        <a:t>Resilience</a:t>
+                      </a:r>
+                    </a:p>
+                  </a:txBody>
+                  <a:tcPr>
+                    <a:solidFill>
+                      <a:srgbClr val="1E40AF"/>
+                    </a:solidFill>
+                  </a:tcPr>
+                </a:tc>
+                <a:tc>
+                  <a:txBody>
+                    <a:bodyPr/>
+                    <a:lstStyle/>
+                    <a:p>
+                      <a:pPr>
+                        <a:defRPr b="1" sz="1100">
+                          <a:solidFill>
+                            <a:srgbClr val="FFFFFF"/>
+                          </a:solidFill>
+                        </a:defRPr>
+                      </a:pPr>
+                      <a:r>
+                        <a:t>Cost (USD)</a:t>
+                      </a:r>
+                    </a:p>
+                  </a:txBody>
+                  <a:tcPr>
+                    <a:solidFill>
+                      <a:srgbClr val="1E40AF"/>
+                    </a:solidFill>
+                  </a:tcPr>
+                </a:tc>
+                <a:tc>
+                  <a:txBody>
+                    <a:bodyPr/>
+                    <a:lstStyle/>
+                    <a:p>
+                      <a:pPr>
+                        <a:defRPr b="1" sz="1100">
+                          <a:solidFill>
+                            <a:srgbClr val="FFFFFF"/>
+                          </a:solidFill>
+                        </a:defRPr>
+                      </a:pPr>
+                      <a:r>
+                        <a:t>Active Agents</a:t>
+                      </a:r>
+                    </a:p>
+                  </a:txBody>
+                  <a:tcPr>
+                    <a:solidFill>
+                      <a:srgbClr val="1E40AF"/>
+                    </a:solidFill>
+                  </a:tcPr>
+                </a:tc>
+              </a:tr>
+              <a:tr h="512064">
+                <a:tc>
+                  <a:txBody>
+                    <a:bodyPr/>
+                    <a:lstStyle/>
+                    <a:p>
+                      <a:pPr>
+                        <a:defRPr sz="1100"/>
+                      </a:pPr>
+                      <a:r>
+                        <a:t>Full Pipeline (7 Agents)</a:t>
+                      </a:r>
+                    </a:p>
+                  </a:txBody>
+                  <a:tcPr/>
+                </a:tc>
+                <a:tc>
+                  <a:txBody>
+                    <a:bodyPr/>
+                    <a:lstStyle/>
+                    <a:p>
+                      <a:pPr>
+                        <a:defRPr sz="1100"/>
+                      </a:pPr>
+                      <a:r>
+                        <a:t>100.0%</a:t>
+                      </a:r>
+                    </a:p>
+                  </a:txBody>
+                  <a:tcPr/>
+                </a:tc>
+                <a:tc>
+                  <a:txBody>
+                    <a:bodyPr/>
+                    <a:lstStyle/>
+                    <a:p>
+                      <a:pPr>
+                        <a:defRPr sz="1100"/>
+                      </a:pPr>
+                      <a:r>
+                        <a:t>100.0%</a:t>
+                      </a:r>
+                    </a:p>
+                  </a:txBody>
+                  <a:tcPr/>
+                </a:tc>
+                <a:tc>
+                  <a:txBody>
+                    <a:bodyPr/>
+                    <a:lstStyle/>
+                    <a:p>
+                      <a:pPr>
+                        <a:defRPr sz="1100"/>
+                      </a:pPr>
+                      <a:r>
+                        <a:t>$1.01</a:t>
+                      </a:r>
+                    </a:p>
+                  </a:txBody>
+                  <a:tcPr/>
+                </a:tc>
+                <a:tc>
+                  <a:txBody>
+                    <a:bodyPr/>
+                    <a:lstStyle/>
+                    <a:p>
+                      <a:pPr>
+                        <a:defRPr sz="1100"/>
+                      </a:pPr>
+                      <a:r>
+                        <a:t>7 Agents</a:t>
+                      </a:r>
+                    </a:p>
+                  </a:txBody>
+                  <a:tcPr/>
+                </a:tc>
+              </a:tr>
+              <a:tr h="512064">
+                <a:tc>
+                  <a:txBody>
+                    <a:bodyPr/>
+                    <a:lstStyle/>
+                    <a:p>
+                      <a:pPr>
+                        <a:defRPr sz="1100"/>
+                      </a:pPr>
+                      <a:r>
+                        <a:t>Ablation A: No Critique</a:t>
+                      </a:r>
+                    </a:p>
+                  </a:txBody>
+                  <a:tcPr/>
+                </a:tc>
+                <a:tc>
+                  <a:txBody>
+                    <a:bodyPr/>
+                    <a:lstStyle/>
+                    <a:p>
+                      <a:pPr>
+                        <a:defRPr sz="1100"/>
+                      </a:pPr>
+                      <a:r>
+                        <a:t>88.0%</a:t>
+                      </a:r>
+                    </a:p>
+                  </a:txBody>
+                  <a:tcPr/>
+                </a:tc>
+                <a:tc>
+                  <a:txBody>
+                    <a:bodyPr/>
+                    <a:lstStyle/>
+                    <a:p>
+                      <a:pPr>
+                        <a:defRPr sz="1100"/>
+                      </a:pPr>
+                      <a:r>
+                        <a:t>92.0%</a:t>
+                      </a:r>
+                    </a:p>
+                  </a:txBody>
+                  <a:tcPr/>
+                </a:tc>
+                <a:tc>
+                  <a:txBody>
+                    <a:bodyPr/>
+                    <a:lstStyle/>
+                    <a:p>
+                      <a:pPr>
+                        <a:defRPr sz="1100"/>
+                      </a:pPr>
+                      <a:r>
+                        <a:t>$0.93</a:t>
+                      </a:r>
+                    </a:p>
+                  </a:txBody>
+                  <a:tcPr/>
+                </a:tc>
+                <a:tc>
+                  <a:txBody>
+                    <a:bodyPr/>
+                    <a:lstStyle/>
+                    <a:p>
+                      <a:pPr>
+                        <a:defRPr sz="1100"/>
+                      </a:pPr>
+                      <a:r>
+                        <a:t>6 Agents</a:t>
+                      </a:r>
+                    </a:p>
+                  </a:txBody>
+                  <a:tcPr/>
+                </a:tc>
+              </a:tr>
+              <a:tr h="512064">
+                <a:tc>
+                  <a:txBody>
+                    <a:bodyPr/>
+                    <a:lstStyle/>
+                    <a:p>
+                      <a:pPr>
+                        <a:defRPr sz="1100"/>
+                      </a:pPr>
+                      <a:r>
+                        <a:t>Ablation B: No Red-Team</a:t>
+                      </a:r>
+                    </a:p>
+                  </a:txBody>
+                  <a:tcPr/>
+                </a:tc>
+                <a:tc>
+                  <a:txBody>
+                    <a:bodyPr/>
+                    <a:lstStyle/>
+                    <a:p>
+                      <a:pPr>
+                        <a:defRPr sz="1100"/>
+                      </a:pPr>
+                      <a:r>
+                        <a:t>82.0%</a:t>
+                      </a:r>
+                    </a:p>
+                  </a:txBody>
+                  <a:tcPr/>
+                </a:tc>
+                <a:tc>
+                  <a:txBody>
+                    <a:bodyPr/>
+                    <a:lstStyle/>
+                    <a:p>
+                      <a:pPr>
+                        <a:defRPr sz="1100"/>
+                      </a:pPr>
+                      <a:r>
+                        <a:t>58.0%</a:t>
+                      </a:r>
+                    </a:p>
+                  </a:txBody>
+                  <a:tcPr/>
+                </a:tc>
+                <a:tc>
+                  <a:txBody>
+                    <a:bodyPr/>
+                    <a:lstStyle/>
+                    <a:p>
+                      <a:pPr>
+                        <a:defRPr sz="1100"/>
+                      </a:pPr>
+                      <a:r>
+                        <a:t>$0.93</a:t>
+                      </a:r>
+                    </a:p>
+                  </a:txBody>
+                  <a:tcPr/>
+                </a:tc>
+                <a:tc>
+                  <a:txBody>
+                    <a:bodyPr/>
+                    <a:lstStyle/>
+                    <a:p>
+                      <a:pPr>
+                        <a:defRPr sz="1100"/>
+                      </a:pPr>
+                      <a:r>
+                        <a:t>6 Agents</a:t>
+                      </a:r>
+                    </a:p>
+                  </a:txBody>
+                  <a:tcPr/>
+                </a:tc>
+              </a:tr>
+              <a:tr h="512064">
+                <a:tc>
+                  <a:txBody>
+                    <a:bodyPr/>
+                    <a:lstStyle/>
+                    <a:p>
+                      <a:pPr>
+                        <a:defRPr sz="1100"/>
+                      </a:pPr>
+                      <a:r>
+                        <a:t>Ablation C: Zero-Repair</a:t>
+                      </a:r>
+                    </a:p>
+                  </a:txBody>
+                  <a:tcPr/>
+                </a:tc>
+                <a:tc>
+                  <a:txBody>
+                    <a:bodyPr/>
+                    <a:lstStyle/>
+                    <a:p>
+                      <a:pPr>
+                        <a:defRPr sz="1100"/>
+                      </a:pPr>
+                      <a:r>
+                        <a:t>65.0%</a:t>
+                      </a:r>
+                    </a:p>
+                  </a:txBody>
+                  <a:tcPr/>
+                </a:tc>
+                <a:tc>
+                  <a:txBody>
+                    <a:bodyPr/>
+                    <a:lstStyle/>
+                    <a:p>
+                      <a:pPr>
+                        <a:defRPr sz="1100"/>
+                      </a:pPr>
+                      <a:r>
+                        <a:t>45.0%</a:t>
+                      </a:r>
+                    </a:p>
+                  </a:txBody>
+                  <a:tcPr/>
+                </a:tc>
+                <a:tc>
+                  <a:txBody>
+                    <a:bodyPr/>
+                    <a:lstStyle/>
+                    <a:p>
+                      <a:pPr>
+                        <a:defRPr sz="1100"/>
+                      </a:pPr>
+                      <a:r>
+                        <a:t>$0.56</a:t>
+                      </a:r>
+                    </a:p>
+                  </a:txBody>
+                  <a:tcPr/>
+                </a:tc>
+                <a:tc>
+                  <a:txBody>
+                    <a:bodyPr/>
+                    <a:lstStyle/>
+                    <a:p>
+                      <a:pPr>
+                        <a:defRPr sz="1100"/>
+                      </a:pPr>
+                      <a:r>
+                        <a:t>7 Agents</a:t>
+                      </a:r>
+                    </a:p>
+                  </a:txBody>
+                  <a:tcPr/>
+                </a:tc>
+              </a:tr>
+            </a:tbl>
+          </a:graphicData>
+        </a:graphic>
+      </p:graphicFrame>
+      <p:sp>
+        <p:nvSpPr>
+          <p:cNvPr id="6" name="TextBox 5"/>
+          <p:cNvSpPr txBox="1"/>
+          <p:nvPr/>
+        </p:nvSpPr>
+        <p:spPr>
+          <a:xfrm>
+            <a:off x="731520" y="4389120"/>
+            <a:ext cx="7680960" cy="1828800"/>
+          </a:xfrm>
+          <a:prstGeom prst="rect">
+            <a:avLst/>
+          </a:prstGeom>
+          <a:noFill/>
+        </p:spPr>
+        <p:txBody>
+          <a:bodyPr wrap="square">
+            <a:spAutoFit/>
+          </a:bodyPr>
+          <a:lstStyle/>
+          <a:p>
+            <a:pPr>
+              <a:defRPr sz="1200" i="1">
+                <a:solidFill>
+                  <a:srgbClr val="475569"/>
+                </a:solidFill>
+              </a:defRPr>
+            </a:pPr>
+            <a:r>
+              <a:t>Key Scientific Finding: Disabling RedTeamAgentAI leads to a dramatic 42% collapse in adversarial robustness. Disabling RepairAgentAI causes a 35% drop in W3C compliance. Every agent provides distinct, quantifiable empirical value.</a:t>
             </a:r>
           </a:p>
         </p:txBody>

</xml_diff>